<commit_message>
Add hands-free audio coaching
</commit_message>
<xml_diff>
--- a/output/BAILOUT_Pitch_Deck.pptx
+++ b/output/BAILOUT_Pitch_Deck.pptx
@@ -2,17 +2,17 @@
 <file path=ppt/presentation.xml><?xml version="1.0" encoding="utf-8"?>
 <p:presentation xmlns:p="http://schemas.openxmlformats.org/presentationml/2006/main">
   <p:sldMasterIdLst>
-    <p:sldMasterId xmlns:r="http://schemas.openxmlformats.org/officeDocument/2006/relationships" id="2147483648" r:id="R0744744016d54f7f"/>
+    <p:sldMasterId xmlns:r="http://schemas.openxmlformats.org/officeDocument/2006/relationships" id="2147483648" r:id="Rd377b0a8148b4ea7"/>
   </p:sldMasterIdLst>
   <p:notesMasterIdLst>
-    <p:notesMasterId xmlns:r="http://schemas.openxmlformats.org/officeDocument/2006/relationships" r:id="R4b2ecaba0f614689"/>
+    <p:notesMasterId xmlns:r="http://schemas.openxmlformats.org/officeDocument/2006/relationships" r:id="Rd62582a234c148dd"/>
   </p:notesMasterIdLst>
   <p:sldIdLst>
-    <p:sldId xmlns:r="http://schemas.openxmlformats.org/officeDocument/2006/relationships" id="256" r:id="R97889e865f664eca"/>
-    <p:sldId xmlns:r="http://schemas.openxmlformats.org/officeDocument/2006/relationships" id="257" r:id="R98e00938bd974867"/>
-    <p:sldId xmlns:r="http://schemas.openxmlformats.org/officeDocument/2006/relationships" id="258" r:id="Rc317de037b6a40b0"/>
-    <p:sldId xmlns:r="http://schemas.openxmlformats.org/officeDocument/2006/relationships" id="259" r:id="R4a997f9ab7ff4003"/>
-    <p:sldId xmlns:r="http://schemas.openxmlformats.org/officeDocument/2006/relationships" id="260" r:id="Re002750040464639"/>
+    <p:sldId xmlns:r="http://schemas.openxmlformats.org/officeDocument/2006/relationships" id="256" r:id="R889cc1e3465844e8"/>
+    <p:sldId xmlns:r="http://schemas.openxmlformats.org/officeDocument/2006/relationships" id="257" r:id="R5c4154551e0c4332"/>
+    <p:sldId xmlns:r="http://schemas.openxmlformats.org/officeDocument/2006/relationships" id="258" r:id="R75b5d24e8cca4a3c"/>
+    <p:sldId xmlns:r="http://schemas.openxmlformats.org/officeDocument/2006/relationships" id="259" r:id="R3ace1e5f4ec74e57"/>
+    <p:sldId xmlns:r="http://schemas.openxmlformats.org/officeDocument/2006/relationships" id="260" r:id="Rd7f5f2950ad248ae"/>
   </p:sldIdLst>
   <p:sldSz cx="12192000" cy="6858000"/>
   <p:notesSz cx="6858000" cy="9144000"/>
@@ -869,7 +869,7 @@
   </p:cSld>
   <p:clrMap bg1="lt1" tx1="dk1" bg2="lt2" tx2="dk2" accent1="accent1" accent2="accent2" accent3="accent3" accent4="accent4" accent5="accent5" accent6="accent6" hlink="hlink" folHlink="folHlink"/>
   <p:sldLayoutIdLst>
-    <p:sldLayoutId xmlns:r="http://schemas.openxmlformats.org/officeDocument/2006/relationships" id="2147483649" r:id="R3c47ea44e768454c"/>
+    <p:sldLayoutId xmlns:r="http://schemas.openxmlformats.org/officeDocument/2006/relationships" id="2147483649" r:id="R755d08c711624256"/>
   </p:sldLayoutIdLst>
   <p:txStyles>
     <p:titleStyle>
@@ -1420,7 +1420,7 @@
           <p:cNvPr id="1" name="">
             <a:extLst xmlns:a="http://schemas.openxmlformats.org/drawingml/2006/main">
               <a:ext uri="{FF2B5EF4-FFF2-40B4-BE49-F238E27FC236}">
-                <a16:creationId xmlns:a16="http://schemas.microsoft.com/office/drawing/2014/main" id="{EC6D2244-10A8-4142-AC49-3719B1376621}"/>
+                <a16:creationId xmlns:a16="http://schemas.microsoft.com/office/drawing/2014/main" id="{DD7B9541-5BE5-4F0E-8BBF-2E04A9422ED3}"/>
               </a:ext>
             </a:extLst>
           </p:cNvPr>
@@ -1453,7 +1453,7 @@
           <p:cNvPr id="2" name="">
             <a:extLst xmlns:a="http://schemas.openxmlformats.org/drawingml/2006/main">
               <a:ext uri="{FF2B5EF4-FFF2-40B4-BE49-F238E27FC236}">
-                <a16:creationId xmlns:a16="http://schemas.microsoft.com/office/drawing/2014/main" id="{27DE0B7F-9220-4B3D-AD42-AAD391A82851}"/>
+                <a16:creationId xmlns:a16="http://schemas.microsoft.com/office/drawing/2014/main" id="{89D6BE2A-8C1D-4FF5-8AE3-89C5347A88FC}"/>
               </a:ext>
             </a:extLst>
           </p:cNvPr>
@@ -1537,7 +1537,7 @@
           <p:cNvPr id="3" name="">
             <a:extLst xmlns:a="http://schemas.openxmlformats.org/drawingml/2006/main">
               <a:ext uri="{FF2B5EF4-FFF2-40B4-BE49-F238E27FC236}">
-                <a16:creationId xmlns:a16="http://schemas.microsoft.com/office/drawing/2014/main" id="{4694C206-BA6D-49BD-A7C8-E64D2BAA3624}"/>
+                <a16:creationId xmlns:a16="http://schemas.microsoft.com/office/drawing/2014/main" id="{552542D4-9F7F-49A6-99B0-3E17BFB8BC27}"/>
               </a:ext>
             </a:extLst>
           </p:cNvPr>
@@ -1587,7 +1587,7 @@
           <p:cNvPr id="4" name="">
             <a:extLst xmlns:a="http://schemas.openxmlformats.org/drawingml/2006/main">
               <a:ext uri="{FF2B5EF4-FFF2-40B4-BE49-F238E27FC236}">
-                <a16:creationId xmlns:a16="http://schemas.microsoft.com/office/drawing/2014/main" id="{530D613E-B335-491A-B6FC-A7773E6A87C8}"/>
+                <a16:creationId xmlns:a16="http://schemas.microsoft.com/office/drawing/2014/main" id="{8B97FC54-92D5-4747-BA02-BCC8CBA61D22}"/>
               </a:ext>
             </a:extLst>
           </p:cNvPr>
@@ -1637,7 +1637,7 @@
           <p:cNvPr id="5" name="">
             <a:extLst xmlns:a="http://schemas.openxmlformats.org/drawingml/2006/main">
               <a:ext uri="{FF2B5EF4-FFF2-40B4-BE49-F238E27FC236}">
-                <a16:creationId xmlns:a16="http://schemas.microsoft.com/office/drawing/2014/main" id="{B6DCF060-6EC5-49EC-9F69-CB310CD775EE}"/>
+                <a16:creationId xmlns:a16="http://schemas.microsoft.com/office/drawing/2014/main" id="{98528752-EA72-4B3B-A4D3-000D11552DF5}"/>
               </a:ext>
             </a:extLst>
           </p:cNvPr>
@@ -1670,7 +1670,7 @@
           <p:cNvPr id="6" name="">
             <a:extLst xmlns:a="http://schemas.openxmlformats.org/drawingml/2006/main">
               <a:ext uri="{FF2B5EF4-FFF2-40B4-BE49-F238E27FC236}">
-                <a16:creationId xmlns:a16="http://schemas.microsoft.com/office/drawing/2014/main" id="{DD6F8A3C-751A-47BD-A5BB-9EC286C70D99}"/>
+                <a16:creationId xmlns:a16="http://schemas.microsoft.com/office/drawing/2014/main" id="{3DFFE7B6-4770-4D2D-AC9A-DCBE44E20B08}"/>
               </a:ext>
             </a:extLst>
           </p:cNvPr>
@@ -1720,7 +1720,7 @@
           <p:cNvPr id="7" name="">
             <a:extLst xmlns:a="http://schemas.openxmlformats.org/drawingml/2006/main">
               <a:ext uri="{FF2B5EF4-FFF2-40B4-BE49-F238E27FC236}">
-                <a16:creationId xmlns:a16="http://schemas.microsoft.com/office/drawing/2014/main" id="{B5C642ED-B9A3-4A5F-A814-FF6A586BEF54}"/>
+                <a16:creationId xmlns:a16="http://schemas.microsoft.com/office/drawing/2014/main" id="{CB27D0C6-477E-47AC-A486-7C187AD60C4E}"/>
               </a:ext>
             </a:extLst>
           </p:cNvPr>
@@ -1787,7 +1787,7 @@
           <p:cNvPr id="8" name="">
             <a:extLst xmlns:a="http://schemas.openxmlformats.org/drawingml/2006/main">
               <a:ext uri="{FF2B5EF4-FFF2-40B4-BE49-F238E27FC236}">
-                <a16:creationId xmlns:a16="http://schemas.microsoft.com/office/drawing/2014/main" id="{1E7A4A99-61C5-4FF5-A923-FEEB50743938}"/>
+                <a16:creationId xmlns:a16="http://schemas.microsoft.com/office/drawing/2014/main" id="{6A129CA4-D203-4CD0-8DA5-B556498DEDBD}"/>
               </a:ext>
             </a:extLst>
           </p:cNvPr>
@@ -1837,7 +1837,7 @@
           <p:cNvPr id="9" name="">
             <a:extLst xmlns:a="http://schemas.openxmlformats.org/drawingml/2006/main">
               <a:ext uri="{FF2B5EF4-FFF2-40B4-BE49-F238E27FC236}">
-                <a16:creationId xmlns:a16="http://schemas.microsoft.com/office/drawing/2014/main" id="{A5033167-8C87-405A-9A99-30935BFE2111}"/>
+                <a16:creationId xmlns:a16="http://schemas.microsoft.com/office/drawing/2014/main" id="{63E0D121-D831-4945-8335-0425448129CE}"/>
               </a:ext>
             </a:extLst>
           </p:cNvPr>
@@ -1887,7 +1887,7 @@
           <p:cNvPr id="10" name="">
             <a:extLst xmlns:a="http://schemas.openxmlformats.org/drawingml/2006/main">
               <a:ext uri="{FF2B5EF4-FFF2-40B4-BE49-F238E27FC236}">
-                <a16:creationId xmlns:a16="http://schemas.microsoft.com/office/drawing/2014/main" id="{D93B245C-1C49-42AE-B562-550204D1BC3D}"/>
+                <a16:creationId xmlns:a16="http://schemas.microsoft.com/office/drawing/2014/main" id="{477C7F78-372B-43EB-980E-04E6DB9A2F6D}"/>
               </a:ext>
             </a:extLst>
           </p:cNvPr>
@@ -1954,7 +1954,7 @@
           <p:cNvPr id="11" name="">
             <a:extLst xmlns:a="http://schemas.openxmlformats.org/drawingml/2006/main">
               <a:ext uri="{FF2B5EF4-FFF2-40B4-BE49-F238E27FC236}">
-                <a16:creationId xmlns:a16="http://schemas.microsoft.com/office/drawing/2014/main" id="{38504369-2D69-4A12-AC84-930679710814}"/>
+                <a16:creationId xmlns:a16="http://schemas.microsoft.com/office/drawing/2014/main" id="{FD685908-78CE-43D5-BFE4-70E01EEC507E}"/>
               </a:ext>
             </a:extLst>
           </p:cNvPr>
@@ -2004,7 +2004,7 @@
           <p:cNvPr id="12" name="">
             <a:extLst xmlns:a="http://schemas.openxmlformats.org/drawingml/2006/main">
               <a:ext uri="{FF2B5EF4-FFF2-40B4-BE49-F238E27FC236}">
-                <a16:creationId xmlns:a16="http://schemas.microsoft.com/office/drawing/2014/main" id="{84A90641-C68E-422C-A447-69C95794DD45}"/>
+                <a16:creationId xmlns:a16="http://schemas.microsoft.com/office/drawing/2014/main" id="{A8BC6194-4018-466E-A323-0E2C857518C5}"/>
               </a:ext>
             </a:extLst>
           </p:cNvPr>
@@ -2039,7 +2039,7 @@
           <p:cNvPr id="13" name="">
             <a:extLst xmlns:a="http://schemas.openxmlformats.org/drawingml/2006/main">
               <a:ext uri="{FF2B5EF4-FFF2-40B4-BE49-F238E27FC236}">
-                <a16:creationId xmlns:a16="http://schemas.microsoft.com/office/drawing/2014/main" id="{7CBA68C8-F493-4114-BF8D-DE348DD84D5D}"/>
+                <a16:creationId xmlns:a16="http://schemas.microsoft.com/office/drawing/2014/main" id="{62CBB4EE-B679-488E-986B-3692A1C43550}"/>
               </a:ext>
             </a:extLst>
           </p:cNvPr>
@@ -2087,7 +2087,7 @@
     </p:spTree>
     <p:extLst>
       <p:ext uri="{BB962C8B-B14F-4D97-AF65-F5344CB8AC3E}">
-        <p14:creationId xmlns:p14="http://schemas.microsoft.com/office/powerpoint/2010/main" val="1517456439"/>
+        <p14:creationId xmlns:p14="http://schemas.microsoft.com/office/powerpoint/2010/main" val="530391533"/>
       </p:ext>
     </p:extLst>
   </p:cSld>
@@ -2118,7 +2118,7 @@
           <p:cNvPr id="1" name="">
             <a:extLst xmlns:a="http://schemas.openxmlformats.org/drawingml/2006/main">
               <a:ext uri="{FF2B5EF4-FFF2-40B4-BE49-F238E27FC236}">
-                <a16:creationId xmlns:a16="http://schemas.microsoft.com/office/drawing/2014/main" id="{A2F91A0D-3620-4336-B9A2-644A70F2F6D0}"/>
+                <a16:creationId xmlns:a16="http://schemas.microsoft.com/office/drawing/2014/main" id="{01BE6DF6-FD83-402F-8ABA-86E28D863EBA}"/>
               </a:ext>
             </a:extLst>
           </p:cNvPr>
@@ -2151,7 +2151,7 @@
           <p:cNvPr id="2" name="">
             <a:extLst xmlns:a="http://schemas.openxmlformats.org/drawingml/2006/main">
               <a:ext uri="{FF2B5EF4-FFF2-40B4-BE49-F238E27FC236}">
-                <a16:creationId xmlns:a16="http://schemas.microsoft.com/office/drawing/2014/main" id="{CFCB8237-237C-4578-8E03-861C57F44CE8}"/>
+                <a16:creationId xmlns:a16="http://schemas.microsoft.com/office/drawing/2014/main" id="{DE260AF3-3F44-49EF-92B2-4C2ECC0ED4DA}"/>
               </a:ext>
             </a:extLst>
           </p:cNvPr>
@@ -2235,7 +2235,7 @@
           <p:cNvPr id="3" name="">
             <a:extLst xmlns:a="http://schemas.openxmlformats.org/drawingml/2006/main">
               <a:ext uri="{FF2B5EF4-FFF2-40B4-BE49-F238E27FC236}">
-                <a16:creationId xmlns:a16="http://schemas.microsoft.com/office/drawing/2014/main" id="{E476F72A-4796-41BE-B30B-3F7677D7D673}"/>
+                <a16:creationId xmlns:a16="http://schemas.microsoft.com/office/drawing/2014/main" id="{A8F29A7E-9964-4921-8657-3B3B0B3C1AF1}"/>
               </a:ext>
             </a:extLst>
           </p:cNvPr>
@@ -2285,7 +2285,7 @@
           <p:cNvPr id="4" name="">
             <a:extLst xmlns:a="http://schemas.openxmlformats.org/drawingml/2006/main">
               <a:ext uri="{FF2B5EF4-FFF2-40B4-BE49-F238E27FC236}">
-                <a16:creationId xmlns:a16="http://schemas.microsoft.com/office/drawing/2014/main" id="{2E4791EA-4C42-45EC-88A7-8E77889D0E86}"/>
+                <a16:creationId xmlns:a16="http://schemas.microsoft.com/office/drawing/2014/main" id="{61407013-E787-4DFE-A1CB-F06050EF95BB}"/>
               </a:ext>
             </a:extLst>
           </p:cNvPr>
@@ -2335,7 +2335,7 @@
           <p:cNvPr id="5" name="">
             <a:extLst xmlns:a="http://schemas.openxmlformats.org/drawingml/2006/main">
               <a:ext uri="{FF2B5EF4-FFF2-40B4-BE49-F238E27FC236}">
-                <a16:creationId xmlns:a16="http://schemas.microsoft.com/office/drawing/2014/main" id="{D3F625A7-C9EC-42AA-889F-CE916ED0D742}"/>
+                <a16:creationId xmlns:a16="http://schemas.microsoft.com/office/drawing/2014/main" id="{61766D3E-4C74-4514-957F-4EE44A298FFE}"/>
               </a:ext>
             </a:extLst>
           </p:cNvPr>
@@ -2368,7 +2368,7 @@
           <p:cNvPr id="6" name="">
             <a:extLst xmlns:a="http://schemas.openxmlformats.org/drawingml/2006/main">
               <a:ext uri="{FF2B5EF4-FFF2-40B4-BE49-F238E27FC236}">
-                <a16:creationId xmlns:a16="http://schemas.microsoft.com/office/drawing/2014/main" id="{268D86DC-AFF2-4BF0-B825-C167FAFA5BE8}"/>
+                <a16:creationId xmlns:a16="http://schemas.microsoft.com/office/drawing/2014/main" id="{1CFA9512-010B-4C7B-A628-A1EAEF88CC18}"/>
               </a:ext>
             </a:extLst>
           </p:cNvPr>
@@ -2418,7 +2418,7 @@
           <p:cNvPr id="7" name="">
             <a:extLst xmlns:a="http://schemas.openxmlformats.org/drawingml/2006/main">
               <a:ext uri="{FF2B5EF4-FFF2-40B4-BE49-F238E27FC236}">
-                <a16:creationId xmlns:a16="http://schemas.microsoft.com/office/drawing/2014/main" id="{7DF9C56F-EF0D-4310-B138-C849812E7755}"/>
+                <a16:creationId xmlns:a16="http://schemas.microsoft.com/office/drawing/2014/main" id="{65F03ABA-215B-46CD-A744-2F4FD3EEBBEE}"/>
               </a:ext>
             </a:extLst>
           </p:cNvPr>
@@ -2512,7 +2512,7 @@
           <p:cNvPr id="8" name="">
             <a:extLst xmlns:a="http://schemas.openxmlformats.org/drawingml/2006/main">
               <a:ext uri="{FF2B5EF4-FFF2-40B4-BE49-F238E27FC236}">
-                <a16:creationId xmlns:a16="http://schemas.microsoft.com/office/drawing/2014/main" id="{4EFA3389-C8F5-42B7-9990-E3DE5595050E}"/>
+                <a16:creationId xmlns:a16="http://schemas.microsoft.com/office/drawing/2014/main" id="{E34B39BB-B099-40C7-A503-F1CC467B4FA1}"/>
               </a:ext>
             </a:extLst>
           </p:cNvPr>
@@ -2562,7 +2562,7 @@
           <p:cNvPr id="9" name="">
             <a:extLst xmlns:a="http://schemas.openxmlformats.org/drawingml/2006/main">
               <a:ext uri="{FF2B5EF4-FFF2-40B4-BE49-F238E27FC236}">
-                <a16:creationId xmlns:a16="http://schemas.microsoft.com/office/drawing/2014/main" id="{E31B3AAD-9D76-4C7C-B104-1E80771CE7D6}"/>
+                <a16:creationId xmlns:a16="http://schemas.microsoft.com/office/drawing/2014/main" id="{BDD26846-2286-4EF5-8671-CFEE5593563E}"/>
               </a:ext>
             </a:extLst>
           </p:cNvPr>
@@ -2612,7 +2612,7 @@
           <p:cNvPr id="10" name="">
             <a:extLst xmlns:a="http://schemas.openxmlformats.org/drawingml/2006/main">
               <a:ext uri="{FF2B5EF4-FFF2-40B4-BE49-F238E27FC236}">
-                <a16:creationId xmlns:a16="http://schemas.microsoft.com/office/drawing/2014/main" id="{0C2397FD-8D4F-485E-93FC-55434BC9D2BA}"/>
+                <a16:creationId xmlns:a16="http://schemas.microsoft.com/office/drawing/2014/main" id="{0756EB54-66FD-4572-86E5-5504A57E5703}"/>
               </a:ext>
             </a:extLst>
           </p:cNvPr>
@@ -2662,7 +2662,7 @@
           <p:cNvPr id="11" name="">
             <a:extLst xmlns:a="http://schemas.openxmlformats.org/drawingml/2006/main">
               <a:ext uri="{FF2B5EF4-FFF2-40B4-BE49-F238E27FC236}">
-                <a16:creationId xmlns:a16="http://schemas.microsoft.com/office/drawing/2014/main" id="{577B5A5D-BF20-4958-ACFC-EF234ABEE02B}"/>
+                <a16:creationId xmlns:a16="http://schemas.microsoft.com/office/drawing/2014/main" id="{EA2177EF-66FB-413B-AADF-85BF21A9435D}"/>
               </a:ext>
             </a:extLst>
           </p:cNvPr>
@@ -2712,7 +2712,7 @@
           <p:cNvPr id="12" name="">
             <a:extLst xmlns:a="http://schemas.openxmlformats.org/drawingml/2006/main">
               <a:ext uri="{FF2B5EF4-FFF2-40B4-BE49-F238E27FC236}">
-                <a16:creationId xmlns:a16="http://schemas.microsoft.com/office/drawing/2014/main" id="{8B47FC83-8E7D-4AB6-BDF4-F8335C4103A8}"/>
+                <a16:creationId xmlns:a16="http://schemas.microsoft.com/office/drawing/2014/main" id="{6A4DED9E-4DAF-4A46-9524-1C3943F73579}"/>
               </a:ext>
             </a:extLst>
           </p:cNvPr>
@@ -2762,7 +2762,7 @@
           <p:cNvPr id="13" name="">
             <a:extLst xmlns:a="http://schemas.openxmlformats.org/drawingml/2006/main">
               <a:ext uri="{FF2B5EF4-FFF2-40B4-BE49-F238E27FC236}">
-                <a16:creationId xmlns:a16="http://schemas.microsoft.com/office/drawing/2014/main" id="{B0DA5532-A7E0-4F21-8E4F-8B6B407C8C06}"/>
+                <a16:creationId xmlns:a16="http://schemas.microsoft.com/office/drawing/2014/main" id="{B6466129-AA5A-4AB4-964A-83468753ED21}"/>
               </a:ext>
             </a:extLst>
           </p:cNvPr>
@@ -2795,7 +2795,7 @@
           <p:cNvPr id="14" name="">
             <a:extLst xmlns:a="http://schemas.openxmlformats.org/drawingml/2006/main">
               <a:ext uri="{FF2B5EF4-FFF2-40B4-BE49-F238E27FC236}">
-                <a16:creationId xmlns:a16="http://schemas.microsoft.com/office/drawing/2014/main" id="{46B3ACFC-20B5-4251-A8E3-C825A5F21822}"/>
+                <a16:creationId xmlns:a16="http://schemas.microsoft.com/office/drawing/2014/main" id="{10084629-8A98-4E42-9A15-5FB15E2721CF}"/>
               </a:ext>
             </a:extLst>
           </p:cNvPr>
@@ -2843,7 +2843,7 @@
     </p:spTree>
     <p:extLst>
       <p:ext uri="{BB962C8B-B14F-4D97-AF65-F5344CB8AC3E}">
-        <p14:creationId xmlns:p14="http://schemas.microsoft.com/office/powerpoint/2010/main" val="641071852"/>
+        <p14:creationId xmlns:p14="http://schemas.microsoft.com/office/powerpoint/2010/main" val="865107039"/>
       </p:ext>
     </p:extLst>
   </p:cSld>
@@ -2874,7 +2874,7 @@
           <p:cNvPr id="1" name="">
             <a:extLst xmlns:a="http://schemas.openxmlformats.org/drawingml/2006/main">
               <a:ext uri="{FF2B5EF4-FFF2-40B4-BE49-F238E27FC236}">
-                <a16:creationId xmlns:a16="http://schemas.microsoft.com/office/drawing/2014/main" id="{8AE27FAF-6448-44F5-A0AE-B16F1D1BC925}"/>
+                <a16:creationId xmlns:a16="http://schemas.microsoft.com/office/drawing/2014/main" id="{7CB91436-7A95-4223-88A2-A4B7EE3035A3}"/>
               </a:ext>
             </a:extLst>
           </p:cNvPr>
@@ -2907,7 +2907,7 @@
           <p:cNvPr id="2" name="">
             <a:extLst xmlns:a="http://schemas.openxmlformats.org/drawingml/2006/main">
               <a:ext uri="{FF2B5EF4-FFF2-40B4-BE49-F238E27FC236}">
-                <a16:creationId xmlns:a16="http://schemas.microsoft.com/office/drawing/2014/main" id="{4C032BD3-1C49-4B9B-A87C-B2A3FF9C08BC}"/>
+                <a16:creationId xmlns:a16="http://schemas.microsoft.com/office/drawing/2014/main" id="{627CE1D4-A09F-4A4E-9AB5-56C5683D6A95}"/>
               </a:ext>
             </a:extLst>
           </p:cNvPr>
@@ -2991,7 +2991,7 @@
           <p:cNvPr id="3" name="">
             <a:extLst xmlns:a="http://schemas.openxmlformats.org/drawingml/2006/main">
               <a:ext uri="{FF2B5EF4-FFF2-40B4-BE49-F238E27FC236}">
-                <a16:creationId xmlns:a16="http://schemas.microsoft.com/office/drawing/2014/main" id="{02428348-7018-4284-92A6-755E53F785D4}"/>
+                <a16:creationId xmlns:a16="http://schemas.microsoft.com/office/drawing/2014/main" id="{EC0718C0-4C36-420E-AE41-042AF9BBDA66}"/>
               </a:ext>
             </a:extLst>
           </p:cNvPr>
@@ -3041,7 +3041,7 @@
           <p:cNvPr id="4" name="">
             <a:extLst xmlns:a="http://schemas.openxmlformats.org/drawingml/2006/main">
               <a:ext uri="{FF2B5EF4-FFF2-40B4-BE49-F238E27FC236}">
-                <a16:creationId xmlns:a16="http://schemas.microsoft.com/office/drawing/2014/main" id="{CBB74F17-BF37-4CFF-B2A0-EE6099E2FA25}"/>
+                <a16:creationId xmlns:a16="http://schemas.microsoft.com/office/drawing/2014/main" id="{75C7820F-C203-41E8-9D8E-0DE365C908FE}"/>
               </a:ext>
             </a:extLst>
           </p:cNvPr>
@@ -3091,7 +3091,7 @@
           <p:cNvPr id="5" name="">
             <a:extLst xmlns:a="http://schemas.openxmlformats.org/drawingml/2006/main">
               <a:ext uri="{FF2B5EF4-FFF2-40B4-BE49-F238E27FC236}">
-                <a16:creationId xmlns:a16="http://schemas.microsoft.com/office/drawing/2014/main" id="{EB464F41-B78D-4A12-B3B6-B4D72FE35462}"/>
+                <a16:creationId xmlns:a16="http://schemas.microsoft.com/office/drawing/2014/main" id="{A2D38141-F5EF-46D7-A4AF-2FD360F00E89}"/>
               </a:ext>
             </a:extLst>
           </p:cNvPr>
@@ -3124,7 +3124,7 @@
           <p:cNvPr id="6" name="">
             <a:extLst xmlns:a="http://schemas.openxmlformats.org/drawingml/2006/main">
               <a:ext uri="{FF2B5EF4-FFF2-40B4-BE49-F238E27FC236}">
-                <a16:creationId xmlns:a16="http://schemas.microsoft.com/office/drawing/2014/main" id="{42ED73C5-3680-4268-9572-FA830B40750D}"/>
+                <a16:creationId xmlns:a16="http://schemas.microsoft.com/office/drawing/2014/main" id="{8AEFC68C-D6DD-406C-8B0C-1B48E29EC165}"/>
               </a:ext>
             </a:extLst>
           </p:cNvPr>
@@ -3174,7 +3174,7 @@
           <p:cNvPr id="7" name="">
             <a:extLst xmlns:a="http://schemas.openxmlformats.org/drawingml/2006/main">
               <a:ext uri="{FF2B5EF4-FFF2-40B4-BE49-F238E27FC236}">
-                <a16:creationId xmlns:a16="http://schemas.microsoft.com/office/drawing/2014/main" id="{AA36BA98-E404-4AA7-B50D-3162E025EE4F}"/>
+                <a16:creationId xmlns:a16="http://schemas.microsoft.com/office/drawing/2014/main" id="{8D278A31-5C55-4DA2-B77E-C792481BB972}"/>
               </a:ext>
             </a:extLst>
           </p:cNvPr>
@@ -3246,7 +3246,7 @@
           <p:cNvPr id="8" name="">
             <a:extLst xmlns:a="http://schemas.openxmlformats.org/drawingml/2006/main">
               <a:ext uri="{FF2B5EF4-FFF2-40B4-BE49-F238E27FC236}">
-                <a16:creationId xmlns:a16="http://schemas.microsoft.com/office/drawing/2014/main" id="{5F7B69F8-8525-4732-A89C-958DD58F781F}"/>
+                <a16:creationId xmlns:a16="http://schemas.microsoft.com/office/drawing/2014/main" id="{00EF5FA4-1103-491F-AB5A-A27A73B4032A}"/>
               </a:ext>
             </a:extLst>
           </p:cNvPr>
@@ -3296,7 +3296,7 @@
           <p:cNvPr id="9" name="">
             <a:extLst xmlns:a="http://schemas.openxmlformats.org/drawingml/2006/main">
               <a:ext uri="{FF2B5EF4-FFF2-40B4-BE49-F238E27FC236}">
-                <a16:creationId xmlns:a16="http://schemas.microsoft.com/office/drawing/2014/main" id="{6B2EC7EE-A67D-41D0-AFC6-A2AC4E5B7501}"/>
+                <a16:creationId xmlns:a16="http://schemas.microsoft.com/office/drawing/2014/main" id="{D514CDF6-5E25-46CF-9121-80FFFF312C29}"/>
               </a:ext>
             </a:extLst>
           </p:cNvPr>
@@ -3346,7 +3346,7 @@
           <p:cNvPr id="10" name="">
             <a:extLst xmlns:a="http://schemas.openxmlformats.org/drawingml/2006/main">
               <a:ext uri="{FF2B5EF4-FFF2-40B4-BE49-F238E27FC236}">
-                <a16:creationId xmlns:a16="http://schemas.microsoft.com/office/drawing/2014/main" id="{D3F71E81-5878-49C7-924D-CA805BEC7D31}"/>
+                <a16:creationId xmlns:a16="http://schemas.microsoft.com/office/drawing/2014/main" id="{6A949131-D81E-490C-853D-A861641A2D37}"/>
               </a:ext>
             </a:extLst>
           </p:cNvPr>
@@ -3396,7 +3396,7 @@
           <p:cNvPr id="11" name="">
             <a:extLst xmlns:a="http://schemas.openxmlformats.org/drawingml/2006/main">
               <a:ext uri="{FF2B5EF4-FFF2-40B4-BE49-F238E27FC236}">
-                <a16:creationId xmlns:a16="http://schemas.microsoft.com/office/drawing/2014/main" id="{E7B4B6CC-0601-44D6-A6A4-CA2EC766029C}"/>
+                <a16:creationId xmlns:a16="http://schemas.microsoft.com/office/drawing/2014/main" id="{5D5B79E5-8BB3-452C-92BA-685A92C287D2}"/>
               </a:ext>
             </a:extLst>
           </p:cNvPr>
@@ -3431,7 +3431,7 @@
           <p:cNvPr id="12" name="">
             <a:extLst xmlns:a="http://schemas.openxmlformats.org/drawingml/2006/main">
               <a:ext uri="{FF2B5EF4-FFF2-40B4-BE49-F238E27FC236}">
-                <a16:creationId xmlns:a16="http://schemas.microsoft.com/office/drawing/2014/main" id="{6D119059-B2F5-4A9B-99C3-594F6D491651}"/>
+                <a16:creationId xmlns:a16="http://schemas.microsoft.com/office/drawing/2014/main" id="{A9F5AB88-DCE3-4ACF-B74C-7BB55D929C3E}"/>
               </a:ext>
             </a:extLst>
           </p:cNvPr>
@@ -3466,7 +3466,7 @@
           <p:cNvPr id="13" name="">
             <a:extLst xmlns:a="http://schemas.openxmlformats.org/drawingml/2006/main">
               <a:ext uri="{FF2B5EF4-FFF2-40B4-BE49-F238E27FC236}">
-                <a16:creationId xmlns:a16="http://schemas.microsoft.com/office/drawing/2014/main" id="{0343E17F-1940-4250-9C69-E3025825279E}"/>
+                <a16:creationId xmlns:a16="http://schemas.microsoft.com/office/drawing/2014/main" id="{F22D2159-A5A6-40CC-AFE1-ABA9F1D58695}"/>
               </a:ext>
             </a:extLst>
           </p:cNvPr>
@@ -3516,7 +3516,7 @@
           <p:cNvPr id="14" name="">
             <a:extLst xmlns:a="http://schemas.openxmlformats.org/drawingml/2006/main">
               <a:ext uri="{FF2B5EF4-FFF2-40B4-BE49-F238E27FC236}">
-                <a16:creationId xmlns:a16="http://schemas.microsoft.com/office/drawing/2014/main" id="{D5426742-FE29-4F3C-8096-731662C7E1B2}"/>
+                <a16:creationId xmlns:a16="http://schemas.microsoft.com/office/drawing/2014/main" id="{4CA79461-4BA3-413C-9C0B-0CD59A55EC58}"/>
               </a:ext>
             </a:extLst>
           </p:cNvPr>
@@ -3566,7 +3566,7 @@
           <p:cNvPr id="15" name="">
             <a:extLst xmlns:a="http://schemas.openxmlformats.org/drawingml/2006/main">
               <a:ext uri="{FF2B5EF4-FFF2-40B4-BE49-F238E27FC236}">
-                <a16:creationId xmlns:a16="http://schemas.microsoft.com/office/drawing/2014/main" id="{0CAF239C-FD3A-4F16-B76B-24E7D323CF97}"/>
+                <a16:creationId xmlns:a16="http://schemas.microsoft.com/office/drawing/2014/main" id="{71CE93F4-CBF4-4221-A351-CF2FB3F648DC}"/>
               </a:ext>
             </a:extLst>
           </p:cNvPr>
@@ -3601,7 +3601,7 @@
           <p:cNvPr id="16" name="">
             <a:extLst xmlns:a="http://schemas.openxmlformats.org/drawingml/2006/main">
               <a:ext uri="{FF2B5EF4-FFF2-40B4-BE49-F238E27FC236}">
-                <a16:creationId xmlns:a16="http://schemas.microsoft.com/office/drawing/2014/main" id="{44CAE566-6DBE-47BB-A76A-D54613B0FCD9}"/>
+                <a16:creationId xmlns:a16="http://schemas.microsoft.com/office/drawing/2014/main" id="{6CE5F6F8-4434-45AB-9746-9E5C43945C92}"/>
               </a:ext>
             </a:extLst>
           </p:cNvPr>
@@ -3636,7 +3636,7 @@
           <p:cNvPr id="17" name="">
             <a:extLst xmlns:a="http://schemas.openxmlformats.org/drawingml/2006/main">
               <a:ext uri="{FF2B5EF4-FFF2-40B4-BE49-F238E27FC236}">
-                <a16:creationId xmlns:a16="http://schemas.microsoft.com/office/drawing/2014/main" id="{6E2D4F08-A12F-4069-9AD8-906F4C4924C6}"/>
+                <a16:creationId xmlns:a16="http://schemas.microsoft.com/office/drawing/2014/main" id="{1085B84F-4CEE-4F11-81CD-885EC4A44575}"/>
               </a:ext>
             </a:extLst>
           </p:cNvPr>
@@ -3686,7 +3686,7 @@
           <p:cNvPr id="18" name="">
             <a:extLst xmlns:a="http://schemas.openxmlformats.org/drawingml/2006/main">
               <a:ext uri="{FF2B5EF4-FFF2-40B4-BE49-F238E27FC236}">
-                <a16:creationId xmlns:a16="http://schemas.microsoft.com/office/drawing/2014/main" id="{0850E93F-3701-4356-B9E9-5431665BE218}"/>
+                <a16:creationId xmlns:a16="http://schemas.microsoft.com/office/drawing/2014/main" id="{FA1143F4-4879-4F57-80EE-9C7579FCFD14}"/>
               </a:ext>
             </a:extLst>
           </p:cNvPr>
@@ -3736,7 +3736,7 @@
           <p:cNvPr id="19" name="">
             <a:extLst xmlns:a="http://schemas.openxmlformats.org/drawingml/2006/main">
               <a:ext uri="{FF2B5EF4-FFF2-40B4-BE49-F238E27FC236}">
-                <a16:creationId xmlns:a16="http://schemas.microsoft.com/office/drawing/2014/main" id="{C50E5185-78B7-42AB-BCEC-219663A40214}"/>
+                <a16:creationId xmlns:a16="http://schemas.microsoft.com/office/drawing/2014/main" id="{261A52AE-CB6C-43AB-A970-CBCF19405DDA}"/>
               </a:ext>
             </a:extLst>
           </p:cNvPr>
@@ -3771,7 +3771,7 @@
           <p:cNvPr id="20" name="">
             <a:extLst xmlns:a="http://schemas.openxmlformats.org/drawingml/2006/main">
               <a:ext uri="{FF2B5EF4-FFF2-40B4-BE49-F238E27FC236}">
-                <a16:creationId xmlns:a16="http://schemas.microsoft.com/office/drawing/2014/main" id="{7C6E63B1-B00B-4D9D-B65F-4DA18CA76F4E}"/>
+                <a16:creationId xmlns:a16="http://schemas.microsoft.com/office/drawing/2014/main" id="{4B9BAC39-3168-479F-9F5A-3E96634F44EF}"/>
               </a:ext>
             </a:extLst>
           </p:cNvPr>
@@ -3806,7 +3806,7 @@
           <p:cNvPr id="21" name="">
             <a:extLst xmlns:a="http://schemas.openxmlformats.org/drawingml/2006/main">
               <a:ext uri="{FF2B5EF4-FFF2-40B4-BE49-F238E27FC236}">
-                <a16:creationId xmlns:a16="http://schemas.microsoft.com/office/drawing/2014/main" id="{E16B96A3-62E5-4BAF-813B-06F77C151CF6}"/>
+                <a16:creationId xmlns:a16="http://schemas.microsoft.com/office/drawing/2014/main" id="{B8C8CB5A-0B4C-4AD6-BEBB-964AE09075D8}"/>
               </a:ext>
             </a:extLst>
           </p:cNvPr>
@@ -3856,7 +3856,7 @@
           <p:cNvPr id="22" name="">
             <a:extLst xmlns:a="http://schemas.openxmlformats.org/drawingml/2006/main">
               <a:ext uri="{FF2B5EF4-FFF2-40B4-BE49-F238E27FC236}">
-                <a16:creationId xmlns:a16="http://schemas.microsoft.com/office/drawing/2014/main" id="{D56FE39B-75D5-47C7-99CB-55D48E43A209}"/>
+                <a16:creationId xmlns:a16="http://schemas.microsoft.com/office/drawing/2014/main" id="{83B2575A-1816-4973-AD9B-9C18C40E0652}"/>
               </a:ext>
             </a:extLst>
           </p:cNvPr>
@@ -3896,7 +3896,7 @@
                   <a:srgbClr val="F2F6F3"/>
                 </a:solidFill>
               </a:rPr>
-              <a:t>Follow live cue cards</a:t>
+              <a:t>Hear hands-free prompts</a:t>
             </a:r>
           </a:p>
         </p:txBody>
@@ -3906,7 +3906,7 @@
           <p:cNvPr id="23" name="">
             <a:extLst xmlns:a="http://schemas.openxmlformats.org/drawingml/2006/main">
               <a:ext uri="{FF2B5EF4-FFF2-40B4-BE49-F238E27FC236}">
-                <a16:creationId xmlns:a16="http://schemas.microsoft.com/office/drawing/2014/main" id="{0B7062DB-DDDF-4637-86D2-8D3E33322ADE}"/>
+                <a16:creationId xmlns:a16="http://schemas.microsoft.com/office/drawing/2014/main" id="{6637BE3E-3FA2-4CD2-AC2B-C3EF4A5F954A}"/>
               </a:ext>
             </a:extLst>
           </p:cNvPr>
@@ -3941,7 +3941,7 @@
           <p:cNvPr id="24" name="">
             <a:extLst xmlns:a="http://schemas.openxmlformats.org/drawingml/2006/main">
               <a:ext uri="{FF2B5EF4-FFF2-40B4-BE49-F238E27FC236}">
-                <a16:creationId xmlns:a16="http://schemas.microsoft.com/office/drawing/2014/main" id="{E69ED05A-F951-46A7-A90F-CF9B1023B7A2}"/>
+                <a16:creationId xmlns:a16="http://schemas.microsoft.com/office/drawing/2014/main" id="{02E9E009-C63C-4FDB-843B-18442C1B416C}"/>
               </a:ext>
             </a:extLst>
           </p:cNvPr>
@@ -3976,7 +3976,7 @@
           <p:cNvPr id="25" name="">
             <a:extLst xmlns:a="http://schemas.openxmlformats.org/drawingml/2006/main">
               <a:ext uri="{FF2B5EF4-FFF2-40B4-BE49-F238E27FC236}">
-                <a16:creationId xmlns:a16="http://schemas.microsoft.com/office/drawing/2014/main" id="{8B662CEA-CF80-4DCA-921C-84184496FE34}"/>
+                <a16:creationId xmlns:a16="http://schemas.microsoft.com/office/drawing/2014/main" id="{ECAD79B6-711A-4C2C-A8B1-ABB37FE3ED51}"/>
               </a:ext>
             </a:extLst>
           </p:cNvPr>
@@ -4026,7 +4026,7 @@
           <p:cNvPr id="26" name="">
             <a:extLst xmlns:a="http://schemas.openxmlformats.org/drawingml/2006/main">
               <a:ext uri="{FF2B5EF4-FFF2-40B4-BE49-F238E27FC236}">
-                <a16:creationId xmlns:a16="http://schemas.microsoft.com/office/drawing/2014/main" id="{44AAF826-A258-4493-80BD-5B0A0C0B19DA}"/>
+                <a16:creationId xmlns:a16="http://schemas.microsoft.com/office/drawing/2014/main" id="{1A77B01F-1DCA-44D5-868D-C588AAC2A4DD}"/>
               </a:ext>
             </a:extLst>
           </p:cNvPr>
@@ -4076,7 +4076,7 @@
           <p:cNvPr id="27" name="">
             <a:extLst xmlns:a="http://schemas.openxmlformats.org/drawingml/2006/main">
               <a:ext uri="{FF2B5EF4-FFF2-40B4-BE49-F238E27FC236}">
-                <a16:creationId xmlns:a16="http://schemas.microsoft.com/office/drawing/2014/main" id="{286F697C-05E3-4C68-A4F3-F325BC4F887A}"/>
+                <a16:creationId xmlns:a16="http://schemas.microsoft.com/office/drawing/2014/main" id="{8C68650A-B352-48DB-B7B3-F3B2C2BD82CE}"/>
               </a:ext>
             </a:extLst>
           </p:cNvPr>
@@ -4124,7 +4124,7 @@
     </p:spTree>
     <p:extLst>
       <p:ext uri="{BB962C8B-B14F-4D97-AF65-F5344CB8AC3E}">
-        <p14:creationId xmlns:p14="http://schemas.microsoft.com/office/powerpoint/2010/main" val="1116772477"/>
+        <p14:creationId xmlns:p14="http://schemas.microsoft.com/office/powerpoint/2010/main" val="1043860515"/>
       </p:ext>
     </p:extLst>
   </p:cSld>
@@ -4155,7 +4155,7 @@
           <p:cNvPr id="1" name="">
             <a:extLst xmlns:a="http://schemas.openxmlformats.org/drawingml/2006/main">
               <a:ext uri="{FF2B5EF4-FFF2-40B4-BE49-F238E27FC236}">
-                <a16:creationId xmlns:a16="http://schemas.microsoft.com/office/drawing/2014/main" id="{1841049E-30C0-429B-A089-5E90C81DEBB1}"/>
+                <a16:creationId xmlns:a16="http://schemas.microsoft.com/office/drawing/2014/main" id="{DC63E3F2-E9D8-48BC-AE01-5F515383DB30}"/>
               </a:ext>
             </a:extLst>
           </p:cNvPr>
@@ -4188,7 +4188,7 @@
           <p:cNvPr id="2" name="">
             <a:extLst xmlns:a="http://schemas.openxmlformats.org/drawingml/2006/main">
               <a:ext uri="{FF2B5EF4-FFF2-40B4-BE49-F238E27FC236}">
-                <a16:creationId xmlns:a16="http://schemas.microsoft.com/office/drawing/2014/main" id="{C7BC39E0-105A-4333-AA95-E227FCAF3AFA}"/>
+                <a16:creationId xmlns:a16="http://schemas.microsoft.com/office/drawing/2014/main" id="{CF3E82BA-93D5-4C5A-93E3-F5A6CBEBD3CE}"/>
               </a:ext>
             </a:extLst>
           </p:cNvPr>
@@ -4272,7 +4272,7 @@
           <p:cNvPr id="3" name="">
             <a:extLst xmlns:a="http://schemas.openxmlformats.org/drawingml/2006/main">
               <a:ext uri="{FF2B5EF4-FFF2-40B4-BE49-F238E27FC236}">
-                <a16:creationId xmlns:a16="http://schemas.microsoft.com/office/drawing/2014/main" id="{57DFB589-2825-4C7C-868A-53ABBCFC5BF8}"/>
+                <a16:creationId xmlns:a16="http://schemas.microsoft.com/office/drawing/2014/main" id="{76A81AD4-A5AA-45D0-8F37-7A8AFF8CF0B0}"/>
               </a:ext>
             </a:extLst>
           </p:cNvPr>
@@ -4322,7 +4322,7 @@
           <p:cNvPr id="4" name="">
             <a:extLst xmlns:a="http://schemas.openxmlformats.org/drawingml/2006/main">
               <a:ext uri="{FF2B5EF4-FFF2-40B4-BE49-F238E27FC236}">
-                <a16:creationId xmlns:a16="http://schemas.microsoft.com/office/drawing/2014/main" id="{B27D6E2D-9D8A-4F83-B7C2-77118845855A}"/>
+                <a16:creationId xmlns:a16="http://schemas.microsoft.com/office/drawing/2014/main" id="{0BD9E499-3E85-4C9D-B993-C3932C820176}"/>
               </a:ext>
             </a:extLst>
           </p:cNvPr>
@@ -4372,7 +4372,7 @@
           <p:cNvPr id="5" name="">
             <a:extLst xmlns:a="http://schemas.openxmlformats.org/drawingml/2006/main">
               <a:ext uri="{FF2B5EF4-FFF2-40B4-BE49-F238E27FC236}">
-                <a16:creationId xmlns:a16="http://schemas.microsoft.com/office/drawing/2014/main" id="{98018C50-0BBA-4097-8F9F-3E4BDA852B08}"/>
+                <a16:creationId xmlns:a16="http://schemas.microsoft.com/office/drawing/2014/main" id="{3FAB9DEF-A758-408F-9D21-29AD5DA98C16}"/>
               </a:ext>
             </a:extLst>
           </p:cNvPr>
@@ -4405,7 +4405,7 @@
           <p:cNvPr id="6" name="">
             <a:extLst xmlns:a="http://schemas.openxmlformats.org/drawingml/2006/main">
               <a:ext uri="{FF2B5EF4-FFF2-40B4-BE49-F238E27FC236}">
-                <a16:creationId xmlns:a16="http://schemas.microsoft.com/office/drawing/2014/main" id="{0E0D37BD-9AF8-4572-B8E9-3F8E11D7238B}"/>
+                <a16:creationId xmlns:a16="http://schemas.microsoft.com/office/drawing/2014/main" id="{970BD5BD-0190-45FB-A55C-D7D78A9E902B}"/>
               </a:ext>
             </a:extLst>
           </p:cNvPr>
@@ -4455,7 +4455,7 @@
           <p:cNvPr id="7" name="">
             <a:extLst xmlns:a="http://schemas.openxmlformats.org/drawingml/2006/main">
               <a:ext uri="{FF2B5EF4-FFF2-40B4-BE49-F238E27FC236}">
-                <a16:creationId xmlns:a16="http://schemas.microsoft.com/office/drawing/2014/main" id="{31AC7418-53AB-4B29-A52B-8F5797280EA7}"/>
+                <a16:creationId xmlns:a16="http://schemas.microsoft.com/office/drawing/2014/main" id="{84581745-710A-4A9C-9A93-902EC98EC890}"/>
               </a:ext>
             </a:extLst>
           </p:cNvPr>
@@ -4573,7 +4573,7 @@
                   <a:srgbClr val="F2F6F3"/>
                 </a:solidFill>
               </a:rPr>
-              <a:t>Keyboard, ringtone, vibration and cue cards all work in-browser.</a:t>
+              <a:t>Keyboard, ringtone, vibration and audio coaching all work in-browser.</a:t>
             </a:r>
           </a:p>
         </p:txBody>
@@ -4583,7 +4583,7 @@
           <p:cNvPr id="8" name="">
             <a:extLst xmlns:a="http://schemas.openxmlformats.org/drawingml/2006/main">
               <a:ext uri="{FF2B5EF4-FFF2-40B4-BE49-F238E27FC236}">
-                <a16:creationId xmlns:a16="http://schemas.microsoft.com/office/drawing/2014/main" id="{A209865E-8907-4478-954F-3327E6B813D4}"/>
+                <a16:creationId xmlns:a16="http://schemas.microsoft.com/office/drawing/2014/main" id="{9A62DEE9-1870-475C-8CA6-952EF343BE45}"/>
               </a:ext>
             </a:extLst>
           </p:cNvPr>
@@ -4633,7 +4633,7 @@
           <p:cNvPr id="9" name="">
             <a:extLst xmlns:a="http://schemas.openxmlformats.org/drawingml/2006/main">
               <a:ext uri="{FF2B5EF4-FFF2-40B4-BE49-F238E27FC236}">
-                <a16:creationId xmlns:a16="http://schemas.microsoft.com/office/drawing/2014/main" id="{C3F34A6E-5527-4B94-8CF9-6A922809EF57}"/>
+                <a16:creationId xmlns:a16="http://schemas.microsoft.com/office/drawing/2014/main" id="{32892154-3512-4AE9-BC03-A353EC65152C}"/>
               </a:ext>
             </a:extLst>
           </p:cNvPr>
@@ -4672,7 +4672,7 @@
           <p:nvPr/>
         </p:nvPicPr>
         <p:blipFill>
-          <a:blip xmlns:r="http://schemas.openxmlformats.org/officeDocument/2006/relationships" xmlns:a="http://schemas.openxmlformats.org/drawingml/2006/main" r:embed="Rf226755af4dd43ab"/>
+          <a:blip xmlns:r="http://schemas.openxmlformats.org/officeDocument/2006/relationships" xmlns:a="http://schemas.openxmlformats.org/drawingml/2006/main" r:embed="Raa3f4963c5f54bfb"/>
           <a:srcRect xmlns:a="http://schemas.openxmlformats.org/drawingml/2006/main" l="5138" t="0" r="5138" b="0"/>
           <a:stretch xmlns:a="http://schemas.openxmlformats.org/drawingml/2006/main">
             <a:fillRect l="0" t="0" r="0" b="0"/>
@@ -4693,7 +4693,7 @@
           <p:cNvPr id="11" name="">
             <a:extLst xmlns:a="http://schemas.openxmlformats.org/drawingml/2006/main">
               <a:ext uri="{FF2B5EF4-FFF2-40B4-BE49-F238E27FC236}">
-                <a16:creationId xmlns:a16="http://schemas.microsoft.com/office/drawing/2014/main" id="{652BF650-4069-4C05-8797-248EEDD45B2E}"/>
+                <a16:creationId xmlns:a16="http://schemas.microsoft.com/office/drawing/2014/main" id="{9874A297-7086-485D-96A9-17E02C17E2BD}"/>
               </a:ext>
             </a:extLst>
           </p:cNvPr>
@@ -4743,7 +4743,7 @@
           <p:cNvPr id="12" name="">
             <a:extLst xmlns:a="http://schemas.openxmlformats.org/drawingml/2006/main">
               <a:ext uri="{FF2B5EF4-FFF2-40B4-BE49-F238E27FC236}">
-                <a16:creationId xmlns:a16="http://schemas.microsoft.com/office/drawing/2014/main" id="{354F913F-652C-49E9-B1B0-AEFC88ACB9A3}"/>
+                <a16:creationId xmlns:a16="http://schemas.microsoft.com/office/drawing/2014/main" id="{CA698B7A-7CB1-4750-B286-E0BF8A255AC3}"/>
               </a:ext>
             </a:extLst>
           </p:cNvPr>
@@ -4793,7 +4793,7 @@
           <p:cNvPr id="13" name="">
             <a:extLst xmlns:a="http://schemas.openxmlformats.org/drawingml/2006/main">
               <a:ext uri="{FF2B5EF4-FFF2-40B4-BE49-F238E27FC236}">
-                <a16:creationId xmlns:a16="http://schemas.microsoft.com/office/drawing/2014/main" id="{46A706F4-1C54-457F-919C-4045C364B496}"/>
+                <a16:creationId xmlns:a16="http://schemas.microsoft.com/office/drawing/2014/main" id="{134D99EF-83F6-48B9-8CB2-71812876EEF1}"/>
               </a:ext>
             </a:extLst>
           </p:cNvPr>
@@ -4826,7 +4826,7 @@
           <p:cNvPr id="14" name="">
             <a:extLst xmlns:a="http://schemas.openxmlformats.org/drawingml/2006/main">
               <a:ext uri="{FF2B5EF4-FFF2-40B4-BE49-F238E27FC236}">
-                <a16:creationId xmlns:a16="http://schemas.microsoft.com/office/drawing/2014/main" id="{E32E7D2B-7736-4C65-B7BF-14AC23CA7B08}"/>
+                <a16:creationId xmlns:a16="http://schemas.microsoft.com/office/drawing/2014/main" id="{EA9E9200-B5B7-4528-B961-7E3D864ABE88}"/>
               </a:ext>
             </a:extLst>
           </p:cNvPr>
@@ -4876,7 +4876,7 @@
           <p:cNvPr id="15" name="">
             <a:extLst xmlns:a="http://schemas.openxmlformats.org/drawingml/2006/main">
               <a:ext uri="{FF2B5EF4-FFF2-40B4-BE49-F238E27FC236}">
-                <a16:creationId xmlns:a16="http://schemas.microsoft.com/office/drawing/2014/main" id="{CEABCEDF-AEAB-47B8-98E4-2C59D3218B5F}"/>
+                <a16:creationId xmlns:a16="http://schemas.microsoft.com/office/drawing/2014/main" id="{B7B9C938-3738-4EC0-9550-CCCE0695206D}"/>
               </a:ext>
             </a:extLst>
           </p:cNvPr>
@@ -4926,7 +4926,7 @@
           <p:cNvPr id="16" name="">
             <a:extLst xmlns:a="http://schemas.openxmlformats.org/drawingml/2006/main">
               <a:ext uri="{FF2B5EF4-FFF2-40B4-BE49-F238E27FC236}">
-                <a16:creationId xmlns:a16="http://schemas.microsoft.com/office/drawing/2014/main" id="{36DA5C32-DAEF-4273-A4AA-D35F04203163}"/>
+                <a16:creationId xmlns:a16="http://schemas.microsoft.com/office/drawing/2014/main" id="{D52CB4A9-9253-4A66-9F01-8FC3B1FEF96D}"/>
               </a:ext>
             </a:extLst>
           </p:cNvPr>
@@ -4959,7 +4959,7 @@
           <p:cNvPr id="17" name="">
             <a:extLst xmlns:a="http://schemas.openxmlformats.org/drawingml/2006/main">
               <a:ext uri="{FF2B5EF4-FFF2-40B4-BE49-F238E27FC236}">
-                <a16:creationId xmlns:a16="http://schemas.microsoft.com/office/drawing/2014/main" id="{C7FF40AD-4401-4752-B7AA-F0E83B3A6622}"/>
+                <a16:creationId xmlns:a16="http://schemas.microsoft.com/office/drawing/2014/main" id="{3F2740E6-3809-4D29-8611-40278CE161D5}"/>
               </a:ext>
             </a:extLst>
           </p:cNvPr>
@@ -5009,7 +5009,7 @@
           <p:cNvPr id="18" name="">
             <a:extLst xmlns:a="http://schemas.openxmlformats.org/drawingml/2006/main">
               <a:ext uri="{FF2B5EF4-FFF2-40B4-BE49-F238E27FC236}">
-                <a16:creationId xmlns:a16="http://schemas.microsoft.com/office/drawing/2014/main" id="{179E2421-3B4B-463E-BA70-6969D88C78E6}"/>
+                <a16:creationId xmlns:a16="http://schemas.microsoft.com/office/drawing/2014/main" id="{EE23F214-0DCB-46D4-8257-545EEE2731D9}"/>
               </a:ext>
             </a:extLst>
           </p:cNvPr>
@@ -5059,7 +5059,7 @@
           <p:cNvPr id="19" name="">
             <a:extLst xmlns:a="http://schemas.openxmlformats.org/drawingml/2006/main">
               <a:ext uri="{FF2B5EF4-FFF2-40B4-BE49-F238E27FC236}">
-                <a16:creationId xmlns:a16="http://schemas.microsoft.com/office/drawing/2014/main" id="{C5F9003A-426C-407C-B556-28F80098392F}"/>
+                <a16:creationId xmlns:a16="http://schemas.microsoft.com/office/drawing/2014/main" id="{6581253B-7435-453F-8838-807E345C8603}"/>
               </a:ext>
             </a:extLst>
           </p:cNvPr>
@@ -5099,7 +5099,7 @@
                   <a:srgbClr val="FFD13D"/>
                 </a:solidFill>
               </a:rPr>
-              <a:t>Ringtone + vibration + teleprompter + mission log</a:t>
+              <a:t>Ringtone + vibration + audio coach + mission log</a:t>
             </a:r>
           </a:p>
         </p:txBody>
@@ -5107,7 +5107,7 @@
     </p:spTree>
     <p:extLst>
       <p:ext uri="{BB962C8B-B14F-4D97-AF65-F5344CB8AC3E}">
-        <p14:creationId xmlns:p14="http://schemas.microsoft.com/office/powerpoint/2010/main" val="753894032"/>
+        <p14:creationId xmlns:p14="http://schemas.microsoft.com/office/powerpoint/2010/main" val="405733674"/>
       </p:ext>
     </p:extLst>
   </p:cSld>
@@ -5138,7 +5138,7 @@
           <p:cNvPr id="1" name="">
             <a:extLst xmlns:a="http://schemas.openxmlformats.org/drawingml/2006/main">
               <a:ext uri="{FF2B5EF4-FFF2-40B4-BE49-F238E27FC236}">
-                <a16:creationId xmlns:a16="http://schemas.microsoft.com/office/drawing/2014/main" id="{C41D705C-0B6D-4832-B7AA-6998C5210526}"/>
+                <a16:creationId xmlns:a16="http://schemas.microsoft.com/office/drawing/2014/main" id="{38C6CE04-B4D3-4309-97AB-F5A16064317D}"/>
               </a:ext>
             </a:extLst>
           </p:cNvPr>
@@ -5171,7 +5171,7 @@
           <p:cNvPr id="2" name="">
             <a:extLst xmlns:a="http://schemas.openxmlformats.org/drawingml/2006/main">
               <a:ext uri="{FF2B5EF4-FFF2-40B4-BE49-F238E27FC236}">
-                <a16:creationId xmlns:a16="http://schemas.microsoft.com/office/drawing/2014/main" id="{05A46F2A-FABC-43AC-9379-D647A31DD241}"/>
+                <a16:creationId xmlns:a16="http://schemas.microsoft.com/office/drawing/2014/main" id="{477783A4-1D95-4564-A9A5-BFD18DEC4FEA}"/>
               </a:ext>
             </a:extLst>
           </p:cNvPr>
@@ -5255,7 +5255,7 @@
           <p:cNvPr id="3" name="">
             <a:extLst xmlns:a="http://schemas.openxmlformats.org/drawingml/2006/main">
               <a:ext uri="{FF2B5EF4-FFF2-40B4-BE49-F238E27FC236}">
-                <a16:creationId xmlns:a16="http://schemas.microsoft.com/office/drawing/2014/main" id="{5BBD5C9B-068C-49AD-86C6-B05B93BC04C2}"/>
+                <a16:creationId xmlns:a16="http://schemas.microsoft.com/office/drawing/2014/main" id="{CB76F714-D09A-42CD-B943-2025E5FE57E9}"/>
               </a:ext>
             </a:extLst>
           </p:cNvPr>
@@ -5305,7 +5305,7 @@
           <p:cNvPr id="4" name="">
             <a:extLst xmlns:a="http://schemas.openxmlformats.org/drawingml/2006/main">
               <a:ext uri="{FF2B5EF4-FFF2-40B4-BE49-F238E27FC236}">
-                <a16:creationId xmlns:a16="http://schemas.microsoft.com/office/drawing/2014/main" id="{CD19F2CC-65D7-4598-9C2F-7DC9DD54638A}"/>
+                <a16:creationId xmlns:a16="http://schemas.microsoft.com/office/drawing/2014/main" id="{25DADE72-A2DC-4228-A215-61D1F925953F}"/>
               </a:ext>
             </a:extLst>
           </p:cNvPr>
@@ -5355,7 +5355,7 @@
           <p:cNvPr id="5" name="">
             <a:extLst xmlns:a="http://schemas.openxmlformats.org/drawingml/2006/main">
               <a:ext uri="{FF2B5EF4-FFF2-40B4-BE49-F238E27FC236}">
-                <a16:creationId xmlns:a16="http://schemas.microsoft.com/office/drawing/2014/main" id="{85CE9968-9AB3-43ED-A92A-65C6733940A8}"/>
+                <a16:creationId xmlns:a16="http://schemas.microsoft.com/office/drawing/2014/main" id="{D38ED2F1-1608-49BF-AA9A-F5467DF3F085}"/>
               </a:ext>
             </a:extLst>
           </p:cNvPr>
@@ -5388,7 +5388,7 @@
           <p:cNvPr id="6" name="">
             <a:extLst xmlns:a="http://schemas.openxmlformats.org/drawingml/2006/main">
               <a:ext uri="{FF2B5EF4-FFF2-40B4-BE49-F238E27FC236}">
-                <a16:creationId xmlns:a16="http://schemas.microsoft.com/office/drawing/2014/main" id="{A4386646-147A-4E92-A4F1-0B6DBE3F3940}"/>
+                <a16:creationId xmlns:a16="http://schemas.microsoft.com/office/drawing/2014/main" id="{31616DFD-32D5-47D4-B17B-0BD4482369A5}"/>
               </a:ext>
             </a:extLst>
           </p:cNvPr>
@@ -5438,7 +5438,7 @@
           <p:cNvPr id="7" name="">
             <a:extLst xmlns:a="http://schemas.openxmlformats.org/drawingml/2006/main">
               <a:ext uri="{FF2B5EF4-FFF2-40B4-BE49-F238E27FC236}">
-                <a16:creationId xmlns:a16="http://schemas.microsoft.com/office/drawing/2014/main" id="{69F25825-388C-45B9-BF91-BCAF003472EC}"/>
+                <a16:creationId xmlns:a16="http://schemas.microsoft.com/office/drawing/2014/main" id="{D7DEFBB8-E98F-4519-AF4B-936F2B9575A9}"/>
               </a:ext>
             </a:extLst>
           </p:cNvPr>
@@ -5532,7 +5532,7 @@
           <p:cNvPr id="8" name="">
             <a:extLst xmlns:a="http://schemas.openxmlformats.org/drawingml/2006/main">
               <a:ext uri="{FF2B5EF4-FFF2-40B4-BE49-F238E27FC236}">
-                <a16:creationId xmlns:a16="http://schemas.microsoft.com/office/drawing/2014/main" id="{0E4DD32B-C9E6-4907-AE28-AF40D0F0B9C6}"/>
+                <a16:creationId xmlns:a16="http://schemas.microsoft.com/office/drawing/2014/main" id="{CC2E6E25-D947-4C9C-A270-9F44F895056A}"/>
               </a:ext>
             </a:extLst>
           </p:cNvPr>
@@ -5582,7 +5582,7 @@
           <p:cNvPr id="9" name="">
             <a:extLst xmlns:a="http://schemas.openxmlformats.org/drawingml/2006/main">
               <a:ext uri="{FF2B5EF4-FFF2-40B4-BE49-F238E27FC236}">
-                <a16:creationId xmlns:a16="http://schemas.microsoft.com/office/drawing/2014/main" id="{2CC696E7-C1D0-435A-BE2B-BE5380038426}"/>
+                <a16:creationId xmlns:a16="http://schemas.microsoft.com/office/drawing/2014/main" id="{F57B3B97-F524-4C2D-8D4F-73AAFFA037AE}"/>
               </a:ext>
             </a:extLst>
           </p:cNvPr>
@@ -5632,7 +5632,7 @@
           <p:cNvPr id="10" name="">
             <a:extLst xmlns:a="http://schemas.openxmlformats.org/drawingml/2006/main">
               <a:ext uri="{FF2B5EF4-FFF2-40B4-BE49-F238E27FC236}">
-                <a16:creationId xmlns:a16="http://schemas.microsoft.com/office/drawing/2014/main" id="{FAD720F4-74F2-4ACA-AAF5-B3E49FAD5BAF}"/>
+                <a16:creationId xmlns:a16="http://schemas.microsoft.com/office/drawing/2014/main" id="{068F3B5D-8653-47A6-8580-AA9F1DE1A12B}"/>
               </a:ext>
             </a:extLst>
           </p:cNvPr>
@@ -5682,7 +5682,7 @@
           <p:cNvPr id="11" name="">
             <a:extLst xmlns:a="http://schemas.openxmlformats.org/drawingml/2006/main">
               <a:ext uri="{FF2B5EF4-FFF2-40B4-BE49-F238E27FC236}">
-                <a16:creationId xmlns:a16="http://schemas.microsoft.com/office/drawing/2014/main" id="{CCF094B0-7E7A-42FB-8101-CE1410192B2B}"/>
+                <a16:creationId xmlns:a16="http://schemas.microsoft.com/office/drawing/2014/main" id="{B31E176B-3F6F-47BA-B046-80CBB6115DAB}"/>
               </a:ext>
             </a:extLst>
           </p:cNvPr>
@@ -5732,7 +5732,7 @@
           <p:cNvPr id="12" name="">
             <a:extLst xmlns:a="http://schemas.openxmlformats.org/drawingml/2006/main">
               <a:ext uri="{FF2B5EF4-FFF2-40B4-BE49-F238E27FC236}">
-                <a16:creationId xmlns:a16="http://schemas.microsoft.com/office/drawing/2014/main" id="{4A415D4C-9EE0-429D-AB77-5AED479A46CB}"/>
+                <a16:creationId xmlns:a16="http://schemas.microsoft.com/office/drawing/2014/main" id="{E61149F4-C020-4DDB-80C6-8B083E42A2B8}"/>
               </a:ext>
             </a:extLst>
           </p:cNvPr>
@@ -5782,7 +5782,7 @@
           <p:cNvPr id="13" name="">
             <a:extLst xmlns:a="http://schemas.openxmlformats.org/drawingml/2006/main">
               <a:ext uri="{FF2B5EF4-FFF2-40B4-BE49-F238E27FC236}">
-                <a16:creationId xmlns:a16="http://schemas.microsoft.com/office/drawing/2014/main" id="{AE0F4026-D3C9-4DDE-B5F8-D70DCE7F0A91}"/>
+                <a16:creationId xmlns:a16="http://schemas.microsoft.com/office/drawing/2014/main" id="{235D8810-49A0-4391-BB95-5EB67712AFAB}"/>
               </a:ext>
             </a:extLst>
           </p:cNvPr>
@@ -5832,7 +5832,7 @@
           <p:cNvPr id="14" name="">
             <a:extLst xmlns:a="http://schemas.openxmlformats.org/drawingml/2006/main">
               <a:ext uri="{FF2B5EF4-FFF2-40B4-BE49-F238E27FC236}">
-                <a16:creationId xmlns:a16="http://schemas.microsoft.com/office/drawing/2014/main" id="{71C9765A-0A25-48DF-B74E-F385A4A076C9}"/>
+                <a16:creationId xmlns:a16="http://schemas.microsoft.com/office/drawing/2014/main" id="{914BE4ED-8B2A-4C6E-81A7-B3145728EEF2}"/>
               </a:ext>
             </a:extLst>
           </p:cNvPr>
@@ -5882,7 +5882,7 @@
           <p:cNvPr id="15" name="">
             <a:extLst xmlns:a="http://schemas.openxmlformats.org/drawingml/2006/main">
               <a:ext uri="{FF2B5EF4-FFF2-40B4-BE49-F238E27FC236}">
-                <a16:creationId xmlns:a16="http://schemas.microsoft.com/office/drawing/2014/main" id="{A6D66D3B-5439-4320-8ADB-1EFAC8AB847F}"/>
+                <a16:creationId xmlns:a16="http://schemas.microsoft.com/office/drawing/2014/main" id="{96B533FC-7B2A-4198-9B26-92C8AE4949FF}"/>
               </a:ext>
             </a:extLst>
           </p:cNvPr>
@@ -5915,7 +5915,7 @@
           <p:cNvPr id="16" name="">
             <a:extLst xmlns:a="http://schemas.openxmlformats.org/drawingml/2006/main">
               <a:ext uri="{FF2B5EF4-FFF2-40B4-BE49-F238E27FC236}">
-                <a16:creationId xmlns:a16="http://schemas.microsoft.com/office/drawing/2014/main" id="{F5CB26DD-B410-4634-98C6-7FA90247DB67}"/>
+                <a16:creationId xmlns:a16="http://schemas.microsoft.com/office/drawing/2014/main" id="{8804EB85-7A60-4903-9862-706B4378F284}"/>
               </a:ext>
             </a:extLst>
           </p:cNvPr>
@@ -5965,7 +5965,7 @@
           <p:cNvPr id="17" name="">
             <a:extLst xmlns:a="http://schemas.openxmlformats.org/drawingml/2006/main">
               <a:ext uri="{FF2B5EF4-FFF2-40B4-BE49-F238E27FC236}">
-                <a16:creationId xmlns:a16="http://schemas.microsoft.com/office/drawing/2014/main" id="{D8D877F4-6E1B-480C-99D3-BBAE499E3390}"/>
+                <a16:creationId xmlns:a16="http://schemas.microsoft.com/office/drawing/2014/main" id="{38F77C52-63F0-4789-8289-BE78899295D0}"/>
               </a:ext>
             </a:extLst>
           </p:cNvPr>
@@ -6000,7 +6000,7 @@
           <p:cNvPr id="18" name="">
             <a:extLst xmlns:a="http://schemas.openxmlformats.org/drawingml/2006/main">
               <a:ext uri="{FF2B5EF4-FFF2-40B4-BE49-F238E27FC236}">
-                <a16:creationId xmlns:a16="http://schemas.microsoft.com/office/drawing/2014/main" id="{1F0CA24A-CA32-4D6F-8A08-96A2D11B2A31}"/>
+                <a16:creationId xmlns:a16="http://schemas.microsoft.com/office/drawing/2014/main" id="{8C6146CE-9DF9-464C-A839-69F9F66DCA89}"/>
               </a:ext>
             </a:extLst>
           </p:cNvPr>
@@ -6048,7 +6048,7 @@
     </p:spTree>
     <p:extLst>
       <p:ext uri="{BB962C8B-B14F-4D97-AF65-F5344CB8AC3E}">
-        <p14:creationId xmlns:p14="http://schemas.microsoft.com/office/powerpoint/2010/main" val="2128742688"/>
+        <p14:creationId xmlns:p14="http://schemas.microsoft.com/office/powerpoint/2010/main" val="1672498826"/>
       </p:ext>
     </p:extLst>
   </p:cSld>

</xml_diff>

<commit_message>
Bundle reliable audio coaching prompts
</commit_message>
<xml_diff>
--- a/output/BAILOUT_Pitch_Deck.pptx
+++ b/output/BAILOUT_Pitch_Deck.pptx
@@ -2,17 +2,17 @@
 <file path=ppt/presentation.xml><?xml version="1.0" encoding="utf-8"?>
 <p:presentation xmlns:p="http://schemas.openxmlformats.org/presentationml/2006/main">
   <p:sldMasterIdLst>
-    <p:sldMasterId xmlns:r="http://schemas.openxmlformats.org/officeDocument/2006/relationships" id="2147483648" r:id="Rd377b0a8148b4ea7"/>
+    <p:sldMasterId xmlns:r="http://schemas.openxmlformats.org/officeDocument/2006/relationships" id="2147483648" r:id="R0113ca4fd2fd43a1"/>
   </p:sldMasterIdLst>
   <p:notesMasterIdLst>
-    <p:notesMasterId xmlns:r="http://schemas.openxmlformats.org/officeDocument/2006/relationships" r:id="Rd62582a234c148dd"/>
+    <p:notesMasterId xmlns:r="http://schemas.openxmlformats.org/officeDocument/2006/relationships" r:id="R6a6b3d7194e7418b"/>
   </p:notesMasterIdLst>
   <p:sldIdLst>
-    <p:sldId xmlns:r="http://schemas.openxmlformats.org/officeDocument/2006/relationships" id="256" r:id="R889cc1e3465844e8"/>
-    <p:sldId xmlns:r="http://schemas.openxmlformats.org/officeDocument/2006/relationships" id="257" r:id="R5c4154551e0c4332"/>
-    <p:sldId xmlns:r="http://schemas.openxmlformats.org/officeDocument/2006/relationships" id="258" r:id="R75b5d24e8cca4a3c"/>
-    <p:sldId xmlns:r="http://schemas.openxmlformats.org/officeDocument/2006/relationships" id="259" r:id="R3ace1e5f4ec74e57"/>
-    <p:sldId xmlns:r="http://schemas.openxmlformats.org/officeDocument/2006/relationships" id="260" r:id="Rd7f5f2950ad248ae"/>
+    <p:sldId xmlns:r="http://schemas.openxmlformats.org/officeDocument/2006/relationships" id="256" r:id="Rbd867f9bd5da41a3"/>
+    <p:sldId xmlns:r="http://schemas.openxmlformats.org/officeDocument/2006/relationships" id="257" r:id="R0d0db4ed96cc4e40"/>
+    <p:sldId xmlns:r="http://schemas.openxmlformats.org/officeDocument/2006/relationships" id="258" r:id="R8035f2b476b240d1"/>
+    <p:sldId xmlns:r="http://schemas.openxmlformats.org/officeDocument/2006/relationships" id="259" r:id="R9c32809cb6754f37"/>
+    <p:sldId xmlns:r="http://schemas.openxmlformats.org/officeDocument/2006/relationships" id="260" r:id="R1d9b0bf738074de2"/>
   </p:sldIdLst>
   <p:sldSz cx="12192000" cy="6858000"/>
   <p:notesSz cx="6858000" cy="9144000"/>
@@ -869,7 +869,7 @@
   </p:cSld>
   <p:clrMap bg1="lt1" tx1="dk1" bg2="lt2" tx2="dk2" accent1="accent1" accent2="accent2" accent3="accent3" accent4="accent4" accent5="accent5" accent6="accent6" hlink="hlink" folHlink="folHlink"/>
   <p:sldLayoutIdLst>
-    <p:sldLayoutId xmlns:r="http://schemas.openxmlformats.org/officeDocument/2006/relationships" id="2147483649" r:id="R755d08c711624256"/>
+    <p:sldLayoutId xmlns:r="http://schemas.openxmlformats.org/officeDocument/2006/relationships" id="2147483649" r:id="Rb8050d0e288b4e87"/>
   </p:sldLayoutIdLst>
   <p:txStyles>
     <p:titleStyle>
@@ -1420,7 +1420,7 @@
           <p:cNvPr id="1" name="">
             <a:extLst xmlns:a="http://schemas.openxmlformats.org/drawingml/2006/main">
               <a:ext uri="{FF2B5EF4-FFF2-40B4-BE49-F238E27FC236}">
-                <a16:creationId xmlns:a16="http://schemas.microsoft.com/office/drawing/2014/main" id="{DD7B9541-5BE5-4F0E-8BBF-2E04A9422ED3}"/>
+                <a16:creationId xmlns:a16="http://schemas.microsoft.com/office/drawing/2014/main" id="{A3D58063-BC2A-4EFF-B37F-CC1A84193AEF}"/>
               </a:ext>
             </a:extLst>
           </p:cNvPr>
@@ -1453,7 +1453,7 @@
           <p:cNvPr id="2" name="">
             <a:extLst xmlns:a="http://schemas.openxmlformats.org/drawingml/2006/main">
               <a:ext uri="{FF2B5EF4-FFF2-40B4-BE49-F238E27FC236}">
-                <a16:creationId xmlns:a16="http://schemas.microsoft.com/office/drawing/2014/main" id="{89D6BE2A-8C1D-4FF5-8AE3-89C5347A88FC}"/>
+                <a16:creationId xmlns:a16="http://schemas.microsoft.com/office/drawing/2014/main" id="{E7DAAB48-8916-449C-98FD-592E3F2A59C9}"/>
               </a:ext>
             </a:extLst>
           </p:cNvPr>
@@ -1537,7 +1537,7 @@
           <p:cNvPr id="3" name="">
             <a:extLst xmlns:a="http://schemas.openxmlformats.org/drawingml/2006/main">
               <a:ext uri="{FF2B5EF4-FFF2-40B4-BE49-F238E27FC236}">
-                <a16:creationId xmlns:a16="http://schemas.microsoft.com/office/drawing/2014/main" id="{552542D4-9F7F-49A6-99B0-3E17BFB8BC27}"/>
+                <a16:creationId xmlns:a16="http://schemas.microsoft.com/office/drawing/2014/main" id="{FA231FC3-071E-4735-AD73-116C6899B51C}"/>
               </a:ext>
             </a:extLst>
           </p:cNvPr>
@@ -1587,7 +1587,7 @@
           <p:cNvPr id="4" name="">
             <a:extLst xmlns:a="http://schemas.openxmlformats.org/drawingml/2006/main">
               <a:ext uri="{FF2B5EF4-FFF2-40B4-BE49-F238E27FC236}">
-                <a16:creationId xmlns:a16="http://schemas.microsoft.com/office/drawing/2014/main" id="{8B97FC54-92D5-4747-BA02-BCC8CBA61D22}"/>
+                <a16:creationId xmlns:a16="http://schemas.microsoft.com/office/drawing/2014/main" id="{B2DD35AD-608D-4E50-85DB-8978E12FC5EF}"/>
               </a:ext>
             </a:extLst>
           </p:cNvPr>
@@ -1637,7 +1637,7 @@
           <p:cNvPr id="5" name="">
             <a:extLst xmlns:a="http://schemas.openxmlformats.org/drawingml/2006/main">
               <a:ext uri="{FF2B5EF4-FFF2-40B4-BE49-F238E27FC236}">
-                <a16:creationId xmlns:a16="http://schemas.microsoft.com/office/drawing/2014/main" id="{98528752-EA72-4B3B-A4D3-000D11552DF5}"/>
+                <a16:creationId xmlns:a16="http://schemas.microsoft.com/office/drawing/2014/main" id="{2DE71C7B-9B17-49E1-9800-4EC330B27A18}"/>
               </a:ext>
             </a:extLst>
           </p:cNvPr>
@@ -1670,7 +1670,7 @@
           <p:cNvPr id="6" name="">
             <a:extLst xmlns:a="http://schemas.openxmlformats.org/drawingml/2006/main">
               <a:ext uri="{FF2B5EF4-FFF2-40B4-BE49-F238E27FC236}">
-                <a16:creationId xmlns:a16="http://schemas.microsoft.com/office/drawing/2014/main" id="{3DFFE7B6-4770-4D2D-AC9A-DCBE44E20B08}"/>
+                <a16:creationId xmlns:a16="http://schemas.microsoft.com/office/drawing/2014/main" id="{B7B9AFFE-C852-4A78-B43C-1BE08808EAA7}"/>
               </a:ext>
             </a:extLst>
           </p:cNvPr>
@@ -1720,7 +1720,7 @@
           <p:cNvPr id="7" name="">
             <a:extLst xmlns:a="http://schemas.openxmlformats.org/drawingml/2006/main">
               <a:ext uri="{FF2B5EF4-FFF2-40B4-BE49-F238E27FC236}">
-                <a16:creationId xmlns:a16="http://schemas.microsoft.com/office/drawing/2014/main" id="{CB27D0C6-477E-47AC-A486-7C187AD60C4E}"/>
+                <a16:creationId xmlns:a16="http://schemas.microsoft.com/office/drawing/2014/main" id="{59389C98-FBA3-4EB1-AA8F-653527360F47}"/>
               </a:ext>
             </a:extLst>
           </p:cNvPr>
@@ -1787,7 +1787,7 @@
           <p:cNvPr id="8" name="">
             <a:extLst xmlns:a="http://schemas.openxmlformats.org/drawingml/2006/main">
               <a:ext uri="{FF2B5EF4-FFF2-40B4-BE49-F238E27FC236}">
-                <a16:creationId xmlns:a16="http://schemas.microsoft.com/office/drawing/2014/main" id="{6A129CA4-D203-4CD0-8DA5-B556498DEDBD}"/>
+                <a16:creationId xmlns:a16="http://schemas.microsoft.com/office/drawing/2014/main" id="{07383503-BC9D-42F8-B8B6-F4452368909F}"/>
               </a:ext>
             </a:extLst>
           </p:cNvPr>
@@ -1837,7 +1837,7 @@
           <p:cNvPr id="9" name="">
             <a:extLst xmlns:a="http://schemas.openxmlformats.org/drawingml/2006/main">
               <a:ext uri="{FF2B5EF4-FFF2-40B4-BE49-F238E27FC236}">
-                <a16:creationId xmlns:a16="http://schemas.microsoft.com/office/drawing/2014/main" id="{63E0D121-D831-4945-8335-0425448129CE}"/>
+                <a16:creationId xmlns:a16="http://schemas.microsoft.com/office/drawing/2014/main" id="{5A571C18-6EE1-4A0A-8CE8-644C46BD8A11}"/>
               </a:ext>
             </a:extLst>
           </p:cNvPr>
@@ -1887,7 +1887,7 @@
           <p:cNvPr id="10" name="">
             <a:extLst xmlns:a="http://schemas.openxmlformats.org/drawingml/2006/main">
               <a:ext uri="{FF2B5EF4-FFF2-40B4-BE49-F238E27FC236}">
-                <a16:creationId xmlns:a16="http://schemas.microsoft.com/office/drawing/2014/main" id="{477C7F78-372B-43EB-980E-04E6DB9A2F6D}"/>
+                <a16:creationId xmlns:a16="http://schemas.microsoft.com/office/drawing/2014/main" id="{CDEC7A4C-9BF9-4038-A23B-F1F0B5C8B6F0}"/>
               </a:ext>
             </a:extLst>
           </p:cNvPr>
@@ -1954,7 +1954,7 @@
           <p:cNvPr id="11" name="">
             <a:extLst xmlns:a="http://schemas.openxmlformats.org/drawingml/2006/main">
               <a:ext uri="{FF2B5EF4-FFF2-40B4-BE49-F238E27FC236}">
-                <a16:creationId xmlns:a16="http://schemas.microsoft.com/office/drawing/2014/main" id="{FD685908-78CE-43D5-BFE4-70E01EEC507E}"/>
+                <a16:creationId xmlns:a16="http://schemas.microsoft.com/office/drawing/2014/main" id="{D8EDC3A7-68B5-4665-9144-AF59021A1A43}"/>
               </a:ext>
             </a:extLst>
           </p:cNvPr>
@@ -2004,7 +2004,7 @@
           <p:cNvPr id="12" name="">
             <a:extLst xmlns:a="http://schemas.openxmlformats.org/drawingml/2006/main">
               <a:ext uri="{FF2B5EF4-FFF2-40B4-BE49-F238E27FC236}">
-                <a16:creationId xmlns:a16="http://schemas.microsoft.com/office/drawing/2014/main" id="{A8BC6194-4018-466E-A323-0E2C857518C5}"/>
+                <a16:creationId xmlns:a16="http://schemas.microsoft.com/office/drawing/2014/main" id="{BCCA1D3C-15F4-44F6-8C1E-6D4D82DE7102}"/>
               </a:ext>
             </a:extLst>
           </p:cNvPr>
@@ -2039,7 +2039,7 @@
           <p:cNvPr id="13" name="">
             <a:extLst xmlns:a="http://schemas.openxmlformats.org/drawingml/2006/main">
               <a:ext uri="{FF2B5EF4-FFF2-40B4-BE49-F238E27FC236}">
-                <a16:creationId xmlns:a16="http://schemas.microsoft.com/office/drawing/2014/main" id="{62CBB4EE-B679-488E-986B-3692A1C43550}"/>
+                <a16:creationId xmlns:a16="http://schemas.microsoft.com/office/drawing/2014/main" id="{DFF5782E-C183-4285-A079-EA4EFF880EC7}"/>
               </a:ext>
             </a:extLst>
           </p:cNvPr>
@@ -2087,7 +2087,7 @@
     </p:spTree>
     <p:extLst>
       <p:ext uri="{BB962C8B-B14F-4D97-AF65-F5344CB8AC3E}">
-        <p14:creationId xmlns:p14="http://schemas.microsoft.com/office/powerpoint/2010/main" val="530391533"/>
+        <p14:creationId xmlns:p14="http://schemas.microsoft.com/office/powerpoint/2010/main" val="970024006"/>
       </p:ext>
     </p:extLst>
   </p:cSld>
@@ -2118,7 +2118,7 @@
           <p:cNvPr id="1" name="">
             <a:extLst xmlns:a="http://schemas.openxmlformats.org/drawingml/2006/main">
               <a:ext uri="{FF2B5EF4-FFF2-40B4-BE49-F238E27FC236}">
-                <a16:creationId xmlns:a16="http://schemas.microsoft.com/office/drawing/2014/main" id="{01BE6DF6-FD83-402F-8ABA-86E28D863EBA}"/>
+                <a16:creationId xmlns:a16="http://schemas.microsoft.com/office/drawing/2014/main" id="{6C7EF1A9-7A86-4A0B-AE4E-91218CD0EC88}"/>
               </a:ext>
             </a:extLst>
           </p:cNvPr>
@@ -2151,7 +2151,7 @@
           <p:cNvPr id="2" name="">
             <a:extLst xmlns:a="http://schemas.openxmlformats.org/drawingml/2006/main">
               <a:ext uri="{FF2B5EF4-FFF2-40B4-BE49-F238E27FC236}">
-                <a16:creationId xmlns:a16="http://schemas.microsoft.com/office/drawing/2014/main" id="{DE260AF3-3F44-49EF-92B2-4C2ECC0ED4DA}"/>
+                <a16:creationId xmlns:a16="http://schemas.microsoft.com/office/drawing/2014/main" id="{767361D2-93F0-42BA-AF06-08FD5C0A12D3}"/>
               </a:ext>
             </a:extLst>
           </p:cNvPr>
@@ -2235,7 +2235,7 @@
           <p:cNvPr id="3" name="">
             <a:extLst xmlns:a="http://schemas.openxmlformats.org/drawingml/2006/main">
               <a:ext uri="{FF2B5EF4-FFF2-40B4-BE49-F238E27FC236}">
-                <a16:creationId xmlns:a16="http://schemas.microsoft.com/office/drawing/2014/main" id="{A8F29A7E-9964-4921-8657-3B3B0B3C1AF1}"/>
+                <a16:creationId xmlns:a16="http://schemas.microsoft.com/office/drawing/2014/main" id="{C5215904-6C23-4096-9350-E35154CE81C8}"/>
               </a:ext>
             </a:extLst>
           </p:cNvPr>
@@ -2285,7 +2285,7 @@
           <p:cNvPr id="4" name="">
             <a:extLst xmlns:a="http://schemas.openxmlformats.org/drawingml/2006/main">
               <a:ext uri="{FF2B5EF4-FFF2-40B4-BE49-F238E27FC236}">
-                <a16:creationId xmlns:a16="http://schemas.microsoft.com/office/drawing/2014/main" id="{61407013-E787-4DFE-A1CB-F06050EF95BB}"/>
+                <a16:creationId xmlns:a16="http://schemas.microsoft.com/office/drawing/2014/main" id="{63115470-0E6C-4245-A4BB-EE5895994243}"/>
               </a:ext>
             </a:extLst>
           </p:cNvPr>
@@ -2335,7 +2335,7 @@
           <p:cNvPr id="5" name="">
             <a:extLst xmlns:a="http://schemas.openxmlformats.org/drawingml/2006/main">
               <a:ext uri="{FF2B5EF4-FFF2-40B4-BE49-F238E27FC236}">
-                <a16:creationId xmlns:a16="http://schemas.microsoft.com/office/drawing/2014/main" id="{61766D3E-4C74-4514-957F-4EE44A298FFE}"/>
+                <a16:creationId xmlns:a16="http://schemas.microsoft.com/office/drawing/2014/main" id="{034C1B99-60AB-4FE0-9565-1E542F03C0D5}"/>
               </a:ext>
             </a:extLst>
           </p:cNvPr>
@@ -2368,7 +2368,7 @@
           <p:cNvPr id="6" name="">
             <a:extLst xmlns:a="http://schemas.openxmlformats.org/drawingml/2006/main">
               <a:ext uri="{FF2B5EF4-FFF2-40B4-BE49-F238E27FC236}">
-                <a16:creationId xmlns:a16="http://schemas.microsoft.com/office/drawing/2014/main" id="{1CFA9512-010B-4C7B-A628-A1EAEF88CC18}"/>
+                <a16:creationId xmlns:a16="http://schemas.microsoft.com/office/drawing/2014/main" id="{3CE27FA0-0D8D-4F2C-A7FC-996489DC0DEC}"/>
               </a:ext>
             </a:extLst>
           </p:cNvPr>
@@ -2418,7 +2418,7 @@
           <p:cNvPr id="7" name="">
             <a:extLst xmlns:a="http://schemas.openxmlformats.org/drawingml/2006/main">
               <a:ext uri="{FF2B5EF4-FFF2-40B4-BE49-F238E27FC236}">
-                <a16:creationId xmlns:a16="http://schemas.microsoft.com/office/drawing/2014/main" id="{65F03ABA-215B-46CD-A744-2F4FD3EEBBEE}"/>
+                <a16:creationId xmlns:a16="http://schemas.microsoft.com/office/drawing/2014/main" id="{026AD990-0233-4D46-ACE4-2392271DE073}"/>
               </a:ext>
             </a:extLst>
           </p:cNvPr>
@@ -2512,7 +2512,7 @@
           <p:cNvPr id="8" name="">
             <a:extLst xmlns:a="http://schemas.openxmlformats.org/drawingml/2006/main">
               <a:ext uri="{FF2B5EF4-FFF2-40B4-BE49-F238E27FC236}">
-                <a16:creationId xmlns:a16="http://schemas.microsoft.com/office/drawing/2014/main" id="{E34B39BB-B099-40C7-A503-F1CC467B4FA1}"/>
+                <a16:creationId xmlns:a16="http://schemas.microsoft.com/office/drawing/2014/main" id="{483618F1-3D09-4C69-8A33-020AFA735883}"/>
               </a:ext>
             </a:extLst>
           </p:cNvPr>
@@ -2562,7 +2562,7 @@
           <p:cNvPr id="9" name="">
             <a:extLst xmlns:a="http://schemas.openxmlformats.org/drawingml/2006/main">
               <a:ext uri="{FF2B5EF4-FFF2-40B4-BE49-F238E27FC236}">
-                <a16:creationId xmlns:a16="http://schemas.microsoft.com/office/drawing/2014/main" id="{BDD26846-2286-4EF5-8671-CFEE5593563E}"/>
+                <a16:creationId xmlns:a16="http://schemas.microsoft.com/office/drawing/2014/main" id="{C0EF10EB-6DBB-41F4-96A3-11E5349C9B40}"/>
               </a:ext>
             </a:extLst>
           </p:cNvPr>
@@ -2612,7 +2612,7 @@
           <p:cNvPr id="10" name="">
             <a:extLst xmlns:a="http://schemas.openxmlformats.org/drawingml/2006/main">
               <a:ext uri="{FF2B5EF4-FFF2-40B4-BE49-F238E27FC236}">
-                <a16:creationId xmlns:a16="http://schemas.microsoft.com/office/drawing/2014/main" id="{0756EB54-66FD-4572-86E5-5504A57E5703}"/>
+                <a16:creationId xmlns:a16="http://schemas.microsoft.com/office/drawing/2014/main" id="{1A3032F6-F46F-45EE-B2B5-F3BAE551919B}"/>
               </a:ext>
             </a:extLst>
           </p:cNvPr>
@@ -2662,7 +2662,7 @@
           <p:cNvPr id="11" name="">
             <a:extLst xmlns:a="http://schemas.openxmlformats.org/drawingml/2006/main">
               <a:ext uri="{FF2B5EF4-FFF2-40B4-BE49-F238E27FC236}">
-                <a16:creationId xmlns:a16="http://schemas.microsoft.com/office/drawing/2014/main" id="{EA2177EF-66FB-413B-AADF-85BF21A9435D}"/>
+                <a16:creationId xmlns:a16="http://schemas.microsoft.com/office/drawing/2014/main" id="{7AD94FD7-ACB2-4255-89AF-4B58ADBA1116}"/>
               </a:ext>
             </a:extLst>
           </p:cNvPr>
@@ -2712,7 +2712,7 @@
           <p:cNvPr id="12" name="">
             <a:extLst xmlns:a="http://schemas.openxmlformats.org/drawingml/2006/main">
               <a:ext uri="{FF2B5EF4-FFF2-40B4-BE49-F238E27FC236}">
-                <a16:creationId xmlns:a16="http://schemas.microsoft.com/office/drawing/2014/main" id="{6A4DED9E-4DAF-4A46-9524-1C3943F73579}"/>
+                <a16:creationId xmlns:a16="http://schemas.microsoft.com/office/drawing/2014/main" id="{0E7BF3A2-53A8-445F-A36D-E8CD95A157C0}"/>
               </a:ext>
             </a:extLst>
           </p:cNvPr>
@@ -2762,7 +2762,7 @@
           <p:cNvPr id="13" name="">
             <a:extLst xmlns:a="http://schemas.openxmlformats.org/drawingml/2006/main">
               <a:ext uri="{FF2B5EF4-FFF2-40B4-BE49-F238E27FC236}">
-                <a16:creationId xmlns:a16="http://schemas.microsoft.com/office/drawing/2014/main" id="{B6466129-AA5A-4AB4-964A-83468753ED21}"/>
+                <a16:creationId xmlns:a16="http://schemas.microsoft.com/office/drawing/2014/main" id="{4D19F826-D3F4-4F57-AD29-D8448DA8F5BC}"/>
               </a:ext>
             </a:extLst>
           </p:cNvPr>
@@ -2795,7 +2795,7 @@
           <p:cNvPr id="14" name="">
             <a:extLst xmlns:a="http://schemas.openxmlformats.org/drawingml/2006/main">
               <a:ext uri="{FF2B5EF4-FFF2-40B4-BE49-F238E27FC236}">
-                <a16:creationId xmlns:a16="http://schemas.microsoft.com/office/drawing/2014/main" id="{10084629-8A98-4E42-9A15-5FB15E2721CF}"/>
+                <a16:creationId xmlns:a16="http://schemas.microsoft.com/office/drawing/2014/main" id="{A1979093-632C-46F1-A109-8B68A74850F5}"/>
               </a:ext>
             </a:extLst>
           </p:cNvPr>
@@ -2843,7 +2843,7 @@
     </p:spTree>
     <p:extLst>
       <p:ext uri="{BB962C8B-B14F-4D97-AF65-F5344CB8AC3E}">
-        <p14:creationId xmlns:p14="http://schemas.microsoft.com/office/powerpoint/2010/main" val="865107039"/>
+        <p14:creationId xmlns:p14="http://schemas.microsoft.com/office/powerpoint/2010/main" val="1045997753"/>
       </p:ext>
     </p:extLst>
   </p:cSld>
@@ -2874,7 +2874,7 @@
           <p:cNvPr id="1" name="">
             <a:extLst xmlns:a="http://schemas.openxmlformats.org/drawingml/2006/main">
               <a:ext uri="{FF2B5EF4-FFF2-40B4-BE49-F238E27FC236}">
-                <a16:creationId xmlns:a16="http://schemas.microsoft.com/office/drawing/2014/main" id="{7CB91436-7A95-4223-88A2-A4B7EE3035A3}"/>
+                <a16:creationId xmlns:a16="http://schemas.microsoft.com/office/drawing/2014/main" id="{C27F8DF4-E9C4-4FBA-9016-E63A8AC3A1BF}"/>
               </a:ext>
             </a:extLst>
           </p:cNvPr>
@@ -2907,7 +2907,7 @@
           <p:cNvPr id="2" name="">
             <a:extLst xmlns:a="http://schemas.openxmlformats.org/drawingml/2006/main">
               <a:ext uri="{FF2B5EF4-FFF2-40B4-BE49-F238E27FC236}">
-                <a16:creationId xmlns:a16="http://schemas.microsoft.com/office/drawing/2014/main" id="{627CE1D4-A09F-4A4E-9AB5-56C5683D6A95}"/>
+                <a16:creationId xmlns:a16="http://schemas.microsoft.com/office/drawing/2014/main" id="{07ED1A39-ADAB-4A1F-BE49-D0A2A8A97F71}"/>
               </a:ext>
             </a:extLst>
           </p:cNvPr>
@@ -2991,7 +2991,7 @@
           <p:cNvPr id="3" name="">
             <a:extLst xmlns:a="http://schemas.openxmlformats.org/drawingml/2006/main">
               <a:ext uri="{FF2B5EF4-FFF2-40B4-BE49-F238E27FC236}">
-                <a16:creationId xmlns:a16="http://schemas.microsoft.com/office/drawing/2014/main" id="{EC0718C0-4C36-420E-AE41-042AF9BBDA66}"/>
+                <a16:creationId xmlns:a16="http://schemas.microsoft.com/office/drawing/2014/main" id="{A769DE67-2570-4804-853D-FF45AEAE7AF6}"/>
               </a:ext>
             </a:extLst>
           </p:cNvPr>
@@ -3041,7 +3041,7 @@
           <p:cNvPr id="4" name="">
             <a:extLst xmlns:a="http://schemas.openxmlformats.org/drawingml/2006/main">
               <a:ext uri="{FF2B5EF4-FFF2-40B4-BE49-F238E27FC236}">
-                <a16:creationId xmlns:a16="http://schemas.microsoft.com/office/drawing/2014/main" id="{75C7820F-C203-41E8-9D8E-0DE365C908FE}"/>
+                <a16:creationId xmlns:a16="http://schemas.microsoft.com/office/drawing/2014/main" id="{F80FD941-CA6B-4C0F-8441-79D234189F78}"/>
               </a:ext>
             </a:extLst>
           </p:cNvPr>
@@ -3091,7 +3091,7 @@
           <p:cNvPr id="5" name="">
             <a:extLst xmlns:a="http://schemas.openxmlformats.org/drawingml/2006/main">
               <a:ext uri="{FF2B5EF4-FFF2-40B4-BE49-F238E27FC236}">
-                <a16:creationId xmlns:a16="http://schemas.microsoft.com/office/drawing/2014/main" id="{A2D38141-F5EF-46D7-A4AF-2FD360F00E89}"/>
+                <a16:creationId xmlns:a16="http://schemas.microsoft.com/office/drawing/2014/main" id="{F129D3A2-056D-42D1-A00D-FACDD57D0673}"/>
               </a:ext>
             </a:extLst>
           </p:cNvPr>
@@ -3124,7 +3124,7 @@
           <p:cNvPr id="6" name="">
             <a:extLst xmlns:a="http://schemas.openxmlformats.org/drawingml/2006/main">
               <a:ext uri="{FF2B5EF4-FFF2-40B4-BE49-F238E27FC236}">
-                <a16:creationId xmlns:a16="http://schemas.microsoft.com/office/drawing/2014/main" id="{8AEFC68C-D6DD-406C-8B0C-1B48E29EC165}"/>
+                <a16:creationId xmlns:a16="http://schemas.microsoft.com/office/drawing/2014/main" id="{962312B3-F3E3-4558-B2D3-E2BEA0F174B8}"/>
               </a:ext>
             </a:extLst>
           </p:cNvPr>
@@ -3174,7 +3174,7 @@
           <p:cNvPr id="7" name="">
             <a:extLst xmlns:a="http://schemas.openxmlformats.org/drawingml/2006/main">
               <a:ext uri="{FF2B5EF4-FFF2-40B4-BE49-F238E27FC236}">
-                <a16:creationId xmlns:a16="http://schemas.microsoft.com/office/drawing/2014/main" id="{8D278A31-5C55-4DA2-B77E-C792481BB972}"/>
+                <a16:creationId xmlns:a16="http://schemas.microsoft.com/office/drawing/2014/main" id="{7550C10F-DD44-47EA-8F0E-4C325A23AEF0}"/>
               </a:ext>
             </a:extLst>
           </p:cNvPr>
@@ -3246,7 +3246,7 @@
           <p:cNvPr id="8" name="">
             <a:extLst xmlns:a="http://schemas.openxmlformats.org/drawingml/2006/main">
               <a:ext uri="{FF2B5EF4-FFF2-40B4-BE49-F238E27FC236}">
-                <a16:creationId xmlns:a16="http://schemas.microsoft.com/office/drawing/2014/main" id="{00EF5FA4-1103-491F-AB5A-A27A73B4032A}"/>
+                <a16:creationId xmlns:a16="http://schemas.microsoft.com/office/drawing/2014/main" id="{3E5C7D42-8589-4789-B5A8-F88D83AB5EC2}"/>
               </a:ext>
             </a:extLst>
           </p:cNvPr>
@@ -3296,7 +3296,7 @@
           <p:cNvPr id="9" name="">
             <a:extLst xmlns:a="http://schemas.openxmlformats.org/drawingml/2006/main">
               <a:ext uri="{FF2B5EF4-FFF2-40B4-BE49-F238E27FC236}">
-                <a16:creationId xmlns:a16="http://schemas.microsoft.com/office/drawing/2014/main" id="{D514CDF6-5E25-46CF-9121-80FFFF312C29}"/>
+                <a16:creationId xmlns:a16="http://schemas.microsoft.com/office/drawing/2014/main" id="{39ED695E-229C-4694-9C2D-43D346526D04}"/>
               </a:ext>
             </a:extLst>
           </p:cNvPr>
@@ -3346,7 +3346,7 @@
           <p:cNvPr id="10" name="">
             <a:extLst xmlns:a="http://schemas.openxmlformats.org/drawingml/2006/main">
               <a:ext uri="{FF2B5EF4-FFF2-40B4-BE49-F238E27FC236}">
-                <a16:creationId xmlns:a16="http://schemas.microsoft.com/office/drawing/2014/main" id="{6A949131-D81E-490C-853D-A861641A2D37}"/>
+                <a16:creationId xmlns:a16="http://schemas.microsoft.com/office/drawing/2014/main" id="{56BFF1C0-8F64-402F-9AD5-E2FA8EFBFA44}"/>
               </a:ext>
             </a:extLst>
           </p:cNvPr>
@@ -3396,7 +3396,7 @@
           <p:cNvPr id="11" name="">
             <a:extLst xmlns:a="http://schemas.openxmlformats.org/drawingml/2006/main">
               <a:ext uri="{FF2B5EF4-FFF2-40B4-BE49-F238E27FC236}">
-                <a16:creationId xmlns:a16="http://schemas.microsoft.com/office/drawing/2014/main" id="{5D5B79E5-8BB3-452C-92BA-685A92C287D2}"/>
+                <a16:creationId xmlns:a16="http://schemas.microsoft.com/office/drawing/2014/main" id="{FB993B8C-47EE-46FE-B64E-5D49370151E3}"/>
               </a:ext>
             </a:extLst>
           </p:cNvPr>
@@ -3431,7 +3431,7 @@
           <p:cNvPr id="12" name="">
             <a:extLst xmlns:a="http://schemas.openxmlformats.org/drawingml/2006/main">
               <a:ext uri="{FF2B5EF4-FFF2-40B4-BE49-F238E27FC236}">
-                <a16:creationId xmlns:a16="http://schemas.microsoft.com/office/drawing/2014/main" id="{A9F5AB88-DCE3-4ACF-B74C-7BB55D929C3E}"/>
+                <a16:creationId xmlns:a16="http://schemas.microsoft.com/office/drawing/2014/main" id="{EC3642DD-7D24-414A-B843-B39FF1354080}"/>
               </a:ext>
             </a:extLst>
           </p:cNvPr>
@@ -3466,7 +3466,7 @@
           <p:cNvPr id="13" name="">
             <a:extLst xmlns:a="http://schemas.openxmlformats.org/drawingml/2006/main">
               <a:ext uri="{FF2B5EF4-FFF2-40B4-BE49-F238E27FC236}">
-                <a16:creationId xmlns:a16="http://schemas.microsoft.com/office/drawing/2014/main" id="{F22D2159-A5A6-40CC-AFE1-ABA9F1D58695}"/>
+                <a16:creationId xmlns:a16="http://schemas.microsoft.com/office/drawing/2014/main" id="{0D3BE9B5-1926-41AA-B022-243239A7D51E}"/>
               </a:ext>
             </a:extLst>
           </p:cNvPr>
@@ -3516,7 +3516,7 @@
           <p:cNvPr id="14" name="">
             <a:extLst xmlns:a="http://schemas.openxmlformats.org/drawingml/2006/main">
               <a:ext uri="{FF2B5EF4-FFF2-40B4-BE49-F238E27FC236}">
-                <a16:creationId xmlns:a16="http://schemas.microsoft.com/office/drawing/2014/main" id="{4CA79461-4BA3-413C-9C0B-0CD59A55EC58}"/>
+                <a16:creationId xmlns:a16="http://schemas.microsoft.com/office/drawing/2014/main" id="{68232158-F42C-4697-8EF5-A3B9B6B9C0BB}"/>
               </a:ext>
             </a:extLst>
           </p:cNvPr>
@@ -3566,7 +3566,7 @@
           <p:cNvPr id="15" name="">
             <a:extLst xmlns:a="http://schemas.openxmlformats.org/drawingml/2006/main">
               <a:ext uri="{FF2B5EF4-FFF2-40B4-BE49-F238E27FC236}">
-                <a16:creationId xmlns:a16="http://schemas.microsoft.com/office/drawing/2014/main" id="{71CE93F4-CBF4-4221-A351-CF2FB3F648DC}"/>
+                <a16:creationId xmlns:a16="http://schemas.microsoft.com/office/drawing/2014/main" id="{26AA6E7D-602A-4C66-945F-4847AA7DFA6C}"/>
               </a:ext>
             </a:extLst>
           </p:cNvPr>
@@ -3601,7 +3601,7 @@
           <p:cNvPr id="16" name="">
             <a:extLst xmlns:a="http://schemas.openxmlformats.org/drawingml/2006/main">
               <a:ext uri="{FF2B5EF4-FFF2-40B4-BE49-F238E27FC236}">
-                <a16:creationId xmlns:a16="http://schemas.microsoft.com/office/drawing/2014/main" id="{6CE5F6F8-4434-45AB-9746-9E5C43945C92}"/>
+                <a16:creationId xmlns:a16="http://schemas.microsoft.com/office/drawing/2014/main" id="{8FA9A398-2910-413E-B8D6-22452C723D12}"/>
               </a:ext>
             </a:extLst>
           </p:cNvPr>
@@ -3636,7 +3636,7 @@
           <p:cNvPr id="17" name="">
             <a:extLst xmlns:a="http://schemas.openxmlformats.org/drawingml/2006/main">
               <a:ext uri="{FF2B5EF4-FFF2-40B4-BE49-F238E27FC236}">
-                <a16:creationId xmlns:a16="http://schemas.microsoft.com/office/drawing/2014/main" id="{1085B84F-4CEE-4F11-81CD-885EC4A44575}"/>
+                <a16:creationId xmlns:a16="http://schemas.microsoft.com/office/drawing/2014/main" id="{E4AAC0F7-9058-41B5-807F-33BE75EA40E7}"/>
               </a:ext>
             </a:extLst>
           </p:cNvPr>
@@ -3686,7 +3686,7 @@
           <p:cNvPr id="18" name="">
             <a:extLst xmlns:a="http://schemas.openxmlformats.org/drawingml/2006/main">
               <a:ext uri="{FF2B5EF4-FFF2-40B4-BE49-F238E27FC236}">
-                <a16:creationId xmlns:a16="http://schemas.microsoft.com/office/drawing/2014/main" id="{FA1143F4-4879-4F57-80EE-9C7579FCFD14}"/>
+                <a16:creationId xmlns:a16="http://schemas.microsoft.com/office/drawing/2014/main" id="{70C1DF9C-509F-408E-92B5-5C69231A371A}"/>
               </a:ext>
             </a:extLst>
           </p:cNvPr>
@@ -3736,7 +3736,7 @@
           <p:cNvPr id="19" name="">
             <a:extLst xmlns:a="http://schemas.openxmlformats.org/drawingml/2006/main">
               <a:ext uri="{FF2B5EF4-FFF2-40B4-BE49-F238E27FC236}">
-                <a16:creationId xmlns:a16="http://schemas.microsoft.com/office/drawing/2014/main" id="{261A52AE-CB6C-43AB-A970-CBCF19405DDA}"/>
+                <a16:creationId xmlns:a16="http://schemas.microsoft.com/office/drawing/2014/main" id="{28FC5AC4-7A9D-4477-9DE0-DFF0699FD0E6}"/>
               </a:ext>
             </a:extLst>
           </p:cNvPr>
@@ -3771,7 +3771,7 @@
           <p:cNvPr id="20" name="">
             <a:extLst xmlns:a="http://schemas.openxmlformats.org/drawingml/2006/main">
               <a:ext uri="{FF2B5EF4-FFF2-40B4-BE49-F238E27FC236}">
-                <a16:creationId xmlns:a16="http://schemas.microsoft.com/office/drawing/2014/main" id="{4B9BAC39-3168-479F-9F5A-3E96634F44EF}"/>
+                <a16:creationId xmlns:a16="http://schemas.microsoft.com/office/drawing/2014/main" id="{297E35ED-8274-43FD-B596-3AD2A80EA169}"/>
               </a:ext>
             </a:extLst>
           </p:cNvPr>
@@ -3806,7 +3806,7 @@
           <p:cNvPr id="21" name="">
             <a:extLst xmlns:a="http://schemas.openxmlformats.org/drawingml/2006/main">
               <a:ext uri="{FF2B5EF4-FFF2-40B4-BE49-F238E27FC236}">
-                <a16:creationId xmlns:a16="http://schemas.microsoft.com/office/drawing/2014/main" id="{B8C8CB5A-0B4C-4AD6-BEBB-964AE09075D8}"/>
+                <a16:creationId xmlns:a16="http://schemas.microsoft.com/office/drawing/2014/main" id="{D31E29B0-5F4E-4C51-A69C-67618D586197}"/>
               </a:ext>
             </a:extLst>
           </p:cNvPr>
@@ -3856,7 +3856,7 @@
           <p:cNvPr id="22" name="">
             <a:extLst xmlns:a="http://schemas.openxmlformats.org/drawingml/2006/main">
               <a:ext uri="{FF2B5EF4-FFF2-40B4-BE49-F238E27FC236}">
-                <a16:creationId xmlns:a16="http://schemas.microsoft.com/office/drawing/2014/main" id="{83B2575A-1816-4973-AD9B-9C18C40E0652}"/>
+                <a16:creationId xmlns:a16="http://schemas.microsoft.com/office/drawing/2014/main" id="{1D63FF12-2224-468E-A157-BD7B3809C116}"/>
               </a:ext>
             </a:extLst>
           </p:cNvPr>
@@ -3906,7 +3906,7 @@
           <p:cNvPr id="23" name="">
             <a:extLst xmlns:a="http://schemas.openxmlformats.org/drawingml/2006/main">
               <a:ext uri="{FF2B5EF4-FFF2-40B4-BE49-F238E27FC236}">
-                <a16:creationId xmlns:a16="http://schemas.microsoft.com/office/drawing/2014/main" id="{6637BE3E-3FA2-4CD2-AC2B-C3EF4A5F954A}"/>
+                <a16:creationId xmlns:a16="http://schemas.microsoft.com/office/drawing/2014/main" id="{9D8FCBF0-E320-4CF3-A8B2-CF2863EB5BE7}"/>
               </a:ext>
             </a:extLst>
           </p:cNvPr>
@@ -3941,7 +3941,7 @@
           <p:cNvPr id="24" name="">
             <a:extLst xmlns:a="http://schemas.openxmlformats.org/drawingml/2006/main">
               <a:ext uri="{FF2B5EF4-FFF2-40B4-BE49-F238E27FC236}">
-                <a16:creationId xmlns:a16="http://schemas.microsoft.com/office/drawing/2014/main" id="{02E9E009-C63C-4FDB-843B-18442C1B416C}"/>
+                <a16:creationId xmlns:a16="http://schemas.microsoft.com/office/drawing/2014/main" id="{04F424CA-8863-4291-B1B2-A565CBF71E8D}"/>
               </a:ext>
             </a:extLst>
           </p:cNvPr>
@@ -3976,7 +3976,7 @@
           <p:cNvPr id="25" name="">
             <a:extLst xmlns:a="http://schemas.openxmlformats.org/drawingml/2006/main">
               <a:ext uri="{FF2B5EF4-FFF2-40B4-BE49-F238E27FC236}">
-                <a16:creationId xmlns:a16="http://schemas.microsoft.com/office/drawing/2014/main" id="{ECAD79B6-711A-4C2C-A8B1-ABB37FE3ED51}"/>
+                <a16:creationId xmlns:a16="http://schemas.microsoft.com/office/drawing/2014/main" id="{674BC63C-E284-423F-A23D-AE18037D3DB6}"/>
               </a:ext>
             </a:extLst>
           </p:cNvPr>
@@ -4026,7 +4026,7 @@
           <p:cNvPr id="26" name="">
             <a:extLst xmlns:a="http://schemas.openxmlformats.org/drawingml/2006/main">
               <a:ext uri="{FF2B5EF4-FFF2-40B4-BE49-F238E27FC236}">
-                <a16:creationId xmlns:a16="http://schemas.microsoft.com/office/drawing/2014/main" id="{1A77B01F-1DCA-44D5-868D-C588AAC2A4DD}"/>
+                <a16:creationId xmlns:a16="http://schemas.microsoft.com/office/drawing/2014/main" id="{76A10737-BFA9-4930-9EAB-FEC87CDABBD4}"/>
               </a:ext>
             </a:extLst>
           </p:cNvPr>
@@ -4076,7 +4076,7 @@
           <p:cNvPr id="27" name="">
             <a:extLst xmlns:a="http://schemas.openxmlformats.org/drawingml/2006/main">
               <a:ext uri="{FF2B5EF4-FFF2-40B4-BE49-F238E27FC236}">
-                <a16:creationId xmlns:a16="http://schemas.microsoft.com/office/drawing/2014/main" id="{8C68650A-B352-48DB-B7B3-F3B2C2BD82CE}"/>
+                <a16:creationId xmlns:a16="http://schemas.microsoft.com/office/drawing/2014/main" id="{B5CD0EF9-C205-4962-B332-2AAA768B39BC}"/>
               </a:ext>
             </a:extLst>
           </p:cNvPr>
@@ -4124,7 +4124,7 @@
     </p:spTree>
     <p:extLst>
       <p:ext uri="{BB962C8B-B14F-4D97-AF65-F5344CB8AC3E}">
-        <p14:creationId xmlns:p14="http://schemas.microsoft.com/office/powerpoint/2010/main" val="1043860515"/>
+        <p14:creationId xmlns:p14="http://schemas.microsoft.com/office/powerpoint/2010/main" val="991378552"/>
       </p:ext>
     </p:extLst>
   </p:cSld>
@@ -4155,7 +4155,7 @@
           <p:cNvPr id="1" name="">
             <a:extLst xmlns:a="http://schemas.openxmlformats.org/drawingml/2006/main">
               <a:ext uri="{FF2B5EF4-FFF2-40B4-BE49-F238E27FC236}">
-                <a16:creationId xmlns:a16="http://schemas.microsoft.com/office/drawing/2014/main" id="{DC63E3F2-E9D8-48BC-AE01-5F515383DB30}"/>
+                <a16:creationId xmlns:a16="http://schemas.microsoft.com/office/drawing/2014/main" id="{9ABAFFC4-EBCA-4710-9262-71F1868EB3C5}"/>
               </a:ext>
             </a:extLst>
           </p:cNvPr>
@@ -4188,7 +4188,7 @@
           <p:cNvPr id="2" name="">
             <a:extLst xmlns:a="http://schemas.openxmlformats.org/drawingml/2006/main">
               <a:ext uri="{FF2B5EF4-FFF2-40B4-BE49-F238E27FC236}">
-                <a16:creationId xmlns:a16="http://schemas.microsoft.com/office/drawing/2014/main" id="{CF3E82BA-93D5-4C5A-93E3-F5A6CBEBD3CE}"/>
+                <a16:creationId xmlns:a16="http://schemas.microsoft.com/office/drawing/2014/main" id="{6FD44BE1-D562-40DB-A5DF-420A645617F0}"/>
               </a:ext>
             </a:extLst>
           </p:cNvPr>
@@ -4272,7 +4272,7 @@
           <p:cNvPr id="3" name="">
             <a:extLst xmlns:a="http://schemas.openxmlformats.org/drawingml/2006/main">
               <a:ext uri="{FF2B5EF4-FFF2-40B4-BE49-F238E27FC236}">
-                <a16:creationId xmlns:a16="http://schemas.microsoft.com/office/drawing/2014/main" id="{76A81AD4-A5AA-45D0-8F37-7A8AFF8CF0B0}"/>
+                <a16:creationId xmlns:a16="http://schemas.microsoft.com/office/drawing/2014/main" id="{15870AAF-897C-4BFE-936D-E9FA78FA2A36}"/>
               </a:ext>
             </a:extLst>
           </p:cNvPr>
@@ -4322,7 +4322,7 @@
           <p:cNvPr id="4" name="">
             <a:extLst xmlns:a="http://schemas.openxmlformats.org/drawingml/2006/main">
               <a:ext uri="{FF2B5EF4-FFF2-40B4-BE49-F238E27FC236}">
-                <a16:creationId xmlns:a16="http://schemas.microsoft.com/office/drawing/2014/main" id="{0BD9E499-3E85-4C9D-B993-C3932C820176}"/>
+                <a16:creationId xmlns:a16="http://schemas.microsoft.com/office/drawing/2014/main" id="{431697EF-798B-49A7-A9FC-EE0157B4BBDA}"/>
               </a:ext>
             </a:extLst>
           </p:cNvPr>
@@ -4372,7 +4372,7 @@
           <p:cNvPr id="5" name="">
             <a:extLst xmlns:a="http://schemas.openxmlformats.org/drawingml/2006/main">
               <a:ext uri="{FF2B5EF4-FFF2-40B4-BE49-F238E27FC236}">
-                <a16:creationId xmlns:a16="http://schemas.microsoft.com/office/drawing/2014/main" id="{3FAB9DEF-A758-408F-9D21-29AD5DA98C16}"/>
+                <a16:creationId xmlns:a16="http://schemas.microsoft.com/office/drawing/2014/main" id="{40C601B0-6EAD-43B5-B6CC-B5C80964CB92}"/>
               </a:ext>
             </a:extLst>
           </p:cNvPr>
@@ -4405,7 +4405,7 @@
           <p:cNvPr id="6" name="">
             <a:extLst xmlns:a="http://schemas.openxmlformats.org/drawingml/2006/main">
               <a:ext uri="{FF2B5EF4-FFF2-40B4-BE49-F238E27FC236}">
-                <a16:creationId xmlns:a16="http://schemas.microsoft.com/office/drawing/2014/main" id="{970BD5BD-0190-45FB-A55C-D7D78A9E902B}"/>
+                <a16:creationId xmlns:a16="http://schemas.microsoft.com/office/drawing/2014/main" id="{DB6FDBE2-F14D-4297-A6AA-74C92BD5089C}"/>
               </a:ext>
             </a:extLst>
           </p:cNvPr>
@@ -4455,7 +4455,7 @@
           <p:cNvPr id="7" name="">
             <a:extLst xmlns:a="http://schemas.openxmlformats.org/drawingml/2006/main">
               <a:ext uri="{FF2B5EF4-FFF2-40B4-BE49-F238E27FC236}">
-                <a16:creationId xmlns:a16="http://schemas.microsoft.com/office/drawing/2014/main" id="{84581745-710A-4A9C-9A93-902EC98EC890}"/>
+                <a16:creationId xmlns:a16="http://schemas.microsoft.com/office/drawing/2014/main" id="{40D5ADE0-4E7C-455E-A90D-287593C6C766}"/>
               </a:ext>
             </a:extLst>
           </p:cNvPr>
@@ -4495,7 +4495,7 @@
                   <a:srgbClr val="F2F6F3"/>
                 </a:solidFill>
               </a:rPr>
-              <a:t>Runs as one HTML file.</a:t>
+              <a:t>Runs as a static browser app.</a:t>
             </a:r>
           </a:p>
           <a:p xmlns:a="http://schemas.openxmlformats.org/drawingml/2006/main">
@@ -4583,7 +4583,7 @@
           <p:cNvPr id="8" name="">
             <a:extLst xmlns:a="http://schemas.openxmlformats.org/drawingml/2006/main">
               <a:ext uri="{FF2B5EF4-FFF2-40B4-BE49-F238E27FC236}">
-                <a16:creationId xmlns:a16="http://schemas.microsoft.com/office/drawing/2014/main" id="{9A62DEE9-1870-475C-8CA6-952EF343BE45}"/>
+                <a16:creationId xmlns:a16="http://schemas.microsoft.com/office/drawing/2014/main" id="{FB8E7E7F-D00C-4131-85BB-F120B3AEC68A}"/>
               </a:ext>
             </a:extLst>
           </p:cNvPr>
@@ -4633,7 +4633,7 @@
           <p:cNvPr id="9" name="">
             <a:extLst xmlns:a="http://schemas.openxmlformats.org/drawingml/2006/main">
               <a:ext uri="{FF2B5EF4-FFF2-40B4-BE49-F238E27FC236}">
-                <a16:creationId xmlns:a16="http://schemas.microsoft.com/office/drawing/2014/main" id="{32892154-3512-4AE9-BC03-A353EC65152C}"/>
+                <a16:creationId xmlns:a16="http://schemas.microsoft.com/office/drawing/2014/main" id="{DAF59649-9816-48E6-91D2-0E86CAD3AC9F}"/>
               </a:ext>
             </a:extLst>
           </p:cNvPr>
@@ -4672,7 +4672,7 @@
           <p:nvPr/>
         </p:nvPicPr>
         <p:blipFill>
-          <a:blip xmlns:r="http://schemas.openxmlformats.org/officeDocument/2006/relationships" xmlns:a="http://schemas.openxmlformats.org/drawingml/2006/main" r:embed="Raa3f4963c5f54bfb"/>
+          <a:blip xmlns:r="http://schemas.openxmlformats.org/officeDocument/2006/relationships" xmlns:a="http://schemas.openxmlformats.org/drawingml/2006/main" r:embed="R75986e40d7c04606"/>
           <a:srcRect xmlns:a="http://schemas.openxmlformats.org/drawingml/2006/main" l="5138" t="0" r="5138" b="0"/>
           <a:stretch xmlns:a="http://schemas.openxmlformats.org/drawingml/2006/main">
             <a:fillRect l="0" t="0" r="0" b="0"/>
@@ -4693,7 +4693,7 @@
           <p:cNvPr id="11" name="">
             <a:extLst xmlns:a="http://schemas.openxmlformats.org/drawingml/2006/main">
               <a:ext uri="{FF2B5EF4-FFF2-40B4-BE49-F238E27FC236}">
-                <a16:creationId xmlns:a16="http://schemas.microsoft.com/office/drawing/2014/main" id="{9874A297-7086-485D-96A9-17E02C17E2BD}"/>
+                <a16:creationId xmlns:a16="http://schemas.microsoft.com/office/drawing/2014/main" id="{4BCDA53B-67C4-4CC2-818D-83A36D6EA077}"/>
               </a:ext>
             </a:extLst>
           </p:cNvPr>
@@ -4743,7 +4743,7 @@
           <p:cNvPr id="12" name="">
             <a:extLst xmlns:a="http://schemas.openxmlformats.org/drawingml/2006/main">
               <a:ext uri="{FF2B5EF4-FFF2-40B4-BE49-F238E27FC236}">
-                <a16:creationId xmlns:a16="http://schemas.microsoft.com/office/drawing/2014/main" id="{CA698B7A-7CB1-4750-B286-E0BF8A255AC3}"/>
+                <a16:creationId xmlns:a16="http://schemas.microsoft.com/office/drawing/2014/main" id="{34FD6E03-5798-4214-9734-AEC781A785B2}"/>
               </a:ext>
             </a:extLst>
           </p:cNvPr>
@@ -4793,7 +4793,7 @@
           <p:cNvPr id="13" name="">
             <a:extLst xmlns:a="http://schemas.openxmlformats.org/drawingml/2006/main">
               <a:ext uri="{FF2B5EF4-FFF2-40B4-BE49-F238E27FC236}">
-                <a16:creationId xmlns:a16="http://schemas.microsoft.com/office/drawing/2014/main" id="{134D99EF-83F6-48B9-8CB2-71812876EEF1}"/>
+                <a16:creationId xmlns:a16="http://schemas.microsoft.com/office/drawing/2014/main" id="{E2DA8AAD-E125-4D67-AF86-4195EA3A8369}"/>
               </a:ext>
             </a:extLst>
           </p:cNvPr>
@@ -4826,7 +4826,7 @@
           <p:cNvPr id="14" name="">
             <a:extLst xmlns:a="http://schemas.openxmlformats.org/drawingml/2006/main">
               <a:ext uri="{FF2B5EF4-FFF2-40B4-BE49-F238E27FC236}">
-                <a16:creationId xmlns:a16="http://schemas.microsoft.com/office/drawing/2014/main" id="{EA9E9200-B5B7-4528-B961-7E3D864ABE88}"/>
+                <a16:creationId xmlns:a16="http://schemas.microsoft.com/office/drawing/2014/main" id="{AF84B622-BBF1-4A8C-9B3F-4D871899EC42}"/>
               </a:ext>
             </a:extLst>
           </p:cNvPr>
@@ -4876,7 +4876,7 @@
           <p:cNvPr id="15" name="">
             <a:extLst xmlns:a="http://schemas.openxmlformats.org/drawingml/2006/main">
               <a:ext uri="{FF2B5EF4-FFF2-40B4-BE49-F238E27FC236}">
-                <a16:creationId xmlns:a16="http://schemas.microsoft.com/office/drawing/2014/main" id="{B7B9C938-3738-4EC0-9550-CCCE0695206D}"/>
+                <a16:creationId xmlns:a16="http://schemas.microsoft.com/office/drawing/2014/main" id="{85EB5E18-D0B1-46D3-BCD3-4B46FB6EB288}"/>
               </a:ext>
             </a:extLst>
           </p:cNvPr>
@@ -4926,7 +4926,7 @@
           <p:cNvPr id="16" name="">
             <a:extLst xmlns:a="http://schemas.openxmlformats.org/drawingml/2006/main">
               <a:ext uri="{FF2B5EF4-FFF2-40B4-BE49-F238E27FC236}">
-                <a16:creationId xmlns:a16="http://schemas.microsoft.com/office/drawing/2014/main" id="{D52CB4A9-9253-4A66-9F01-8FC3B1FEF96D}"/>
+                <a16:creationId xmlns:a16="http://schemas.microsoft.com/office/drawing/2014/main" id="{9BEF8F17-A497-4A0A-A3D8-A885C30BD652}"/>
               </a:ext>
             </a:extLst>
           </p:cNvPr>
@@ -4959,7 +4959,7 @@
           <p:cNvPr id="17" name="">
             <a:extLst xmlns:a="http://schemas.openxmlformats.org/drawingml/2006/main">
               <a:ext uri="{FF2B5EF4-FFF2-40B4-BE49-F238E27FC236}">
-                <a16:creationId xmlns:a16="http://schemas.microsoft.com/office/drawing/2014/main" id="{3F2740E6-3809-4D29-8611-40278CE161D5}"/>
+                <a16:creationId xmlns:a16="http://schemas.microsoft.com/office/drawing/2014/main" id="{82CE7E71-88F0-4E00-88F4-0E9762821076}"/>
               </a:ext>
             </a:extLst>
           </p:cNvPr>
@@ -5009,7 +5009,7 @@
           <p:cNvPr id="18" name="">
             <a:extLst xmlns:a="http://schemas.openxmlformats.org/drawingml/2006/main">
               <a:ext uri="{FF2B5EF4-FFF2-40B4-BE49-F238E27FC236}">
-                <a16:creationId xmlns:a16="http://schemas.microsoft.com/office/drawing/2014/main" id="{EE23F214-0DCB-46D4-8257-545EEE2731D9}"/>
+                <a16:creationId xmlns:a16="http://schemas.microsoft.com/office/drawing/2014/main" id="{60751BC5-EF02-44F8-BC4A-5AA55CA12568}"/>
               </a:ext>
             </a:extLst>
           </p:cNvPr>
@@ -5059,7 +5059,7 @@
           <p:cNvPr id="19" name="">
             <a:extLst xmlns:a="http://schemas.openxmlformats.org/drawingml/2006/main">
               <a:ext uri="{FF2B5EF4-FFF2-40B4-BE49-F238E27FC236}">
-                <a16:creationId xmlns:a16="http://schemas.microsoft.com/office/drawing/2014/main" id="{6581253B-7435-453F-8838-807E345C8603}"/>
+                <a16:creationId xmlns:a16="http://schemas.microsoft.com/office/drawing/2014/main" id="{23386EE5-FA9C-4FF7-8312-771BEFA9FB10}"/>
               </a:ext>
             </a:extLst>
           </p:cNvPr>
@@ -5107,7 +5107,7 @@
     </p:spTree>
     <p:extLst>
       <p:ext uri="{BB962C8B-B14F-4D97-AF65-F5344CB8AC3E}">
-        <p14:creationId xmlns:p14="http://schemas.microsoft.com/office/powerpoint/2010/main" val="405733674"/>
+        <p14:creationId xmlns:p14="http://schemas.microsoft.com/office/powerpoint/2010/main" val="1860632278"/>
       </p:ext>
     </p:extLst>
   </p:cSld>
@@ -5138,7 +5138,7 @@
           <p:cNvPr id="1" name="">
             <a:extLst xmlns:a="http://schemas.openxmlformats.org/drawingml/2006/main">
               <a:ext uri="{FF2B5EF4-FFF2-40B4-BE49-F238E27FC236}">
-                <a16:creationId xmlns:a16="http://schemas.microsoft.com/office/drawing/2014/main" id="{38C6CE04-B4D3-4309-97AB-F5A16064317D}"/>
+                <a16:creationId xmlns:a16="http://schemas.microsoft.com/office/drawing/2014/main" id="{03B94EEC-BC74-4B16-AC30-589A7F0409DF}"/>
               </a:ext>
             </a:extLst>
           </p:cNvPr>
@@ -5171,7 +5171,7 @@
           <p:cNvPr id="2" name="">
             <a:extLst xmlns:a="http://schemas.openxmlformats.org/drawingml/2006/main">
               <a:ext uri="{FF2B5EF4-FFF2-40B4-BE49-F238E27FC236}">
-                <a16:creationId xmlns:a16="http://schemas.microsoft.com/office/drawing/2014/main" id="{477783A4-1D95-4564-A9A5-BFD18DEC4FEA}"/>
+                <a16:creationId xmlns:a16="http://schemas.microsoft.com/office/drawing/2014/main" id="{6652CF69-ECD0-4ED9-9BA9-157747DF67CA}"/>
               </a:ext>
             </a:extLst>
           </p:cNvPr>
@@ -5255,7 +5255,7 @@
           <p:cNvPr id="3" name="">
             <a:extLst xmlns:a="http://schemas.openxmlformats.org/drawingml/2006/main">
               <a:ext uri="{FF2B5EF4-FFF2-40B4-BE49-F238E27FC236}">
-                <a16:creationId xmlns:a16="http://schemas.microsoft.com/office/drawing/2014/main" id="{CB76F714-D09A-42CD-B943-2025E5FE57E9}"/>
+                <a16:creationId xmlns:a16="http://schemas.microsoft.com/office/drawing/2014/main" id="{CD751924-DF96-41D3-A374-BB7F4F1E4FC5}"/>
               </a:ext>
             </a:extLst>
           </p:cNvPr>
@@ -5305,7 +5305,7 @@
           <p:cNvPr id="4" name="">
             <a:extLst xmlns:a="http://schemas.openxmlformats.org/drawingml/2006/main">
               <a:ext uri="{FF2B5EF4-FFF2-40B4-BE49-F238E27FC236}">
-                <a16:creationId xmlns:a16="http://schemas.microsoft.com/office/drawing/2014/main" id="{25DADE72-A2DC-4228-A215-61D1F925953F}"/>
+                <a16:creationId xmlns:a16="http://schemas.microsoft.com/office/drawing/2014/main" id="{2BBF895E-4479-4CAB-9743-66A499529053}"/>
               </a:ext>
             </a:extLst>
           </p:cNvPr>
@@ -5355,7 +5355,7 @@
           <p:cNvPr id="5" name="">
             <a:extLst xmlns:a="http://schemas.openxmlformats.org/drawingml/2006/main">
               <a:ext uri="{FF2B5EF4-FFF2-40B4-BE49-F238E27FC236}">
-                <a16:creationId xmlns:a16="http://schemas.microsoft.com/office/drawing/2014/main" id="{D38ED2F1-1608-49BF-AA9A-F5467DF3F085}"/>
+                <a16:creationId xmlns:a16="http://schemas.microsoft.com/office/drawing/2014/main" id="{8D376462-5000-4FE5-B080-412C8C9B24A0}"/>
               </a:ext>
             </a:extLst>
           </p:cNvPr>
@@ -5388,7 +5388,7 @@
           <p:cNvPr id="6" name="">
             <a:extLst xmlns:a="http://schemas.openxmlformats.org/drawingml/2006/main">
               <a:ext uri="{FF2B5EF4-FFF2-40B4-BE49-F238E27FC236}">
-                <a16:creationId xmlns:a16="http://schemas.microsoft.com/office/drawing/2014/main" id="{31616DFD-32D5-47D4-B17B-0BD4482369A5}"/>
+                <a16:creationId xmlns:a16="http://schemas.microsoft.com/office/drawing/2014/main" id="{11D483EC-C2C4-44BC-8A2C-25C9F8E65816}"/>
               </a:ext>
             </a:extLst>
           </p:cNvPr>
@@ -5438,7 +5438,7 @@
           <p:cNvPr id="7" name="">
             <a:extLst xmlns:a="http://schemas.openxmlformats.org/drawingml/2006/main">
               <a:ext uri="{FF2B5EF4-FFF2-40B4-BE49-F238E27FC236}">
-                <a16:creationId xmlns:a16="http://schemas.microsoft.com/office/drawing/2014/main" id="{D7DEFBB8-E98F-4519-AF4B-936F2B9575A9}"/>
+                <a16:creationId xmlns:a16="http://schemas.microsoft.com/office/drawing/2014/main" id="{7339A98D-D700-45C7-9317-0668F41A772F}"/>
               </a:ext>
             </a:extLst>
           </p:cNvPr>
@@ -5532,7 +5532,7 @@
           <p:cNvPr id="8" name="">
             <a:extLst xmlns:a="http://schemas.openxmlformats.org/drawingml/2006/main">
               <a:ext uri="{FF2B5EF4-FFF2-40B4-BE49-F238E27FC236}">
-                <a16:creationId xmlns:a16="http://schemas.microsoft.com/office/drawing/2014/main" id="{CC2E6E25-D947-4C9C-A270-9F44F895056A}"/>
+                <a16:creationId xmlns:a16="http://schemas.microsoft.com/office/drawing/2014/main" id="{B7E5CEA8-9836-4969-9846-69E959934D16}"/>
               </a:ext>
             </a:extLst>
           </p:cNvPr>
@@ -5582,7 +5582,7 @@
           <p:cNvPr id="9" name="">
             <a:extLst xmlns:a="http://schemas.openxmlformats.org/drawingml/2006/main">
               <a:ext uri="{FF2B5EF4-FFF2-40B4-BE49-F238E27FC236}">
-                <a16:creationId xmlns:a16="http://schemas.microsoft.com/office/drawing/2014/main" id="{F57B3B97-F524-4C2D-8D4F-73AAFFA037AE}"/>
+                <a16:creationId xmlns:a16="http://schemas.microsoft.com/office/drawing/2014/main" id="{BCC75126-A49C-41AD-8167-F510B5C52D49}"/>
               </a:ext>
             </a:extLst>
           </p:cNvPr>
@@ -5632,7 +5632,7 @@
           <p:cNvPr id="10" name="">
             <a:extLst xmlns:a="http://schemas.openxmlformats.org/drawingml/2006/main">
               <a:ext uri="{FF2B5EF4-FFF2-40B4-BE49-F238E27FC236}">
-                <a16:creationId xmlns:a16="http://schemas.microsoft.com/office/drawing/2014/main" id="{068F3B5D-8653-47A6-8580-AA9F1DE1A12B}"/>
+                <a16:creationId xmlns:a16="http://schemas.microsoft.com/office/drawing/2014/main" id="{2DFAA8EA-61A7-496B-8B83-F7F38F9B73CC}"/>
               </a:ext>
             </a:extLst>
           </p:cNvPr>
@@ -5682,7 +5682,7 @@
           <p:cNvPr id="11" name="">
             <a:extLst xmlns:a="http://schemas.openxmlformats.org/drawingml/2006/main">
               <a:ext uri="{FF2B5EF4-FFF2-40B4-BE49-F238E27FC236}">
-                <a16:creationId xmlns:a16="http://schemas.microsoft.com/office/drawing/2014/main" id="{B31E176B-3F6F-47BA-B046-80CBB6115DAB}"/>
+                <a16:creationId xmlns:a16="http://schemas.microsoft.com/office/drawing/2014/main" id="{54BA8DB1-204C-4439-A4C5-2FDAC67E72CD}"/>
               </a:ext>
             </a:extLst>
           </p:cNvPr>
@@ -5732,7 +5732,7 @@
           <p:cNvPr id="12" name="">
             <a:extLst xmlns:a="http://schemas.openxmlformats.org/drawingml/2006/main">
               <a:ext uri="{FF2B5EF4-FFF2-40B4-BE49-F238E27FC236}">
-                <a16:creationId xmlns:a16="http://schemas.microsoft.com/office/drawing/2014/main" id="{E61149F4-C020-4DDB-80C6-8B083E42A2B8}"/>
+                <a16:creationId xmlns:a16="http://schemas.microsoft.com/office/drawing/2014/main" id="{79F668CA-8908-42DF-BC55-AF4EF74A9740}"/>
               </a:ext>
             </a:extLst>
           </p:cNvPr>
@@ -5782,7 +5782,7 @@
           <p:cNvPr id="13" name="">
             <a:extLst xmlns:a="http://schemas.openxmlformats.org/drawingml/2006/main">
               <a:ext uri="{FF2B5EF4-FFF2-40B4-BE49-F238E27FC236}">
-                <a16:creationId xmlns:a16="http://schemas.microsoft.com/office/drawing/2014/main" id="{235D8810-49A0-4391-BB95-5EB67712AFAB}"/>
+                <a16:creationId xmlns:a16="http://schemas.microsoft.com/office/drawing/2014/main" id="{9BB212D0-95A8-4062-BD3C-E2EB3B7AC225}"/>
               </a:ext>
             </a:extLst>
           </p:cNvPr>
@@ -5832,7 +5832,7 @@
           <p:cNvPr id="14" name="">
             <a:extLst xmlns:a="http://schemas.openxmlformats.org/drawingml/2006/main">
               <a:ext uri="{FF2B5EF4-FFF2-40B4-BE49-F238E27FC236}">
-                <a16:creationId xmlns:a16="http://schemas.microsoft.com/office/drawing/2014/main" id="{914BE4ED-8B2A-4C6E-81A7-B3145728EEF2}"/>
+                <a16:creationId xmlns:a16="http://schemas.microsoft.com/office/drawing/2014/main" id="{E3607C3A-11E8-4408-A09C-6F9277F52AEE}"/>
               </a:ext>
             </a:extLst>
           </p:cNvPr>
@@ -5882,7 +5882,7 @@
           <p:cNvPr id="15" name="">
             <a:extLst xmlns:a="http://schemas.openxmlformats.org/drawingml/2006/main">
               <a:ext uri="{FF2B5EF4-FFF2-40B4-BE49-F238E27FC236}">
-                <a16:creationId xmlns:a16="http://schemas.microsoft.com/office/drawing/2014/main" id="{96B533FC-7B2A-4198-9B26-92C8AE4949FF}"/>
+                <a16:creationId xmlns:a16="http://schemas.microsoft.com/office/drawing/2014/main" id="{3742F73D-A370-47BD-894A-B6F4F8283A4C}"/>
               </a:ext>
             </a:extLst>
           </p:cNvPr>
@@ -5915,7 +5915,7 @@
           <p:cNvPr id="16" name="">
             <a:extLst xmlns:a="http://schemas.openxmlformats.org/drawingml/2006/main">
               <a:ext uri="{FF2B5EF4-FFF2-40B4-BE49-F238E27FC236}">
-                <a16:creationId xmlns:a16="http://schemas.microsoft.com/office/drawing/2014/main" id="{8804EB85-7A60-4903-9862-706B4378F284}"/>
+                <a16:creationId xmlns:a16="http://schemas.microsoft.com/office/drawing/2014/main" id="{EE870A8E-1245-41DF-BA24-6E6DDE1AD896}"/>
               </a:ext>
             </a:extLst>
           </p:cNvPr>
@@ -5965,7 +5965,7 @@
           <p:cNvPr id="17" name="">
             <a:extLst xmlns:a="http://schemas.openxmlformats.org/drawingml/2006/main">
               <a:ext uri="{FF2B5EF4-FFF2-40B4-BE49-F238E27FC236}">
-                <a16:creationId xmlns:a16="http://schemas.microsoft.com/office/drawing/2014/main" id="{38F77C52-63F0-4789-8289-BE78899295D0}"/>
+                <a16:creationId xmlns:a16="http://schemas.microsoft.com/office/drawing/2014/main" id="{0DF3395B-BA07-401A-A233-859736EBF56F}"/>
               </a:ext>
             </a:extLst>
           </p:cNvPr>
@@ -6000,7 +6000,7 @@
           <p:cNvPr id="18" name="">
             <a:extLst xmlns:a="http://schemas.openxmlformats.org/drawingml/2006/main">
               <a:ext uri="{FF2B5EF4-FFF2-40B4-BE49-F238E27FC236}">
-                <a16:creationId xmlns:a16="http://schemas.microsoft.com/office/drawing/2014/main" id="{8C6146CE-9DF9-464C-A839-69F9F66DCA89}"/>
+                <a16:creationId xmlns:a16="http://schemas.microsoft.com/office/drawing/2014/main" id="{D398448F-0F9E-4271-8DA7-04CE122CB33C}"/>
               </a:ext>
             </a:extLst>
           </p:cNvPr>
@@ -6048,7 +6048,7 @@
     </p:spTree>
     <p:extLst>
       <p:ext uri="{BB962C8B-B14F-4D97-AF65-F5344CB8AC3E}">
-        <p14:creationId xmlns:p14="http://schemas.microsoft.com/office/powerpoint/2010/main" val="1672498826"/>
+        <p14:creationId xmlns:p14="http://schemas.microsoft.com/office/powerpoint/2010/main" val="1132052268"/>
       </p:ext>
     </p:extLst>
   </p:cSld>

</xml_diff>